<commit_message>
refactor and customize the configuration
</commit_message>
<xml_diff>
--- a/docs/presentation/CloudLens DevOps Dashboard for Resource and Cost Monitoring.pptx
+++ b/docs/presentation/CloudLens DevOps Dashboard for Resource and Cost Monitoring.pptx
@@ -13,6 +13,8 @@
     <p:sldId id="261" r:id="rId7"/>
     <p:sldId id="262" r:id="rId8"/>
     <p:sldId id="263" r:id="rId9"/>
+    <p:sldId id="272" r:id="rId25"/>
+    <p:sldId id="273" r:id="rId26"/>
     <p:sldId id="264" r:id="rId10"/>
     <p:sldId id="265" r:id="rId11"/>
     <p:sldId id="266" r:id="rId12"/>
@@ -699,10 +701,8 @@
           <a:lstStyle/>
           <a:p>
             <a:r>
-              <a:rPr lang="en-US" dirty="0"/>
-              <a:t>Cost optimisation is ten percent of the marks, so two angles. For the clouds we monitor: the recommendations engine compares each resource’s 30-day cost with its 7-day utilisation. On the demo data the biggest item is an idle GPU training VM. For our own platform: Cost Explorer charges a cent per request, so we never poll it every minute; the daily sync re-reads three days and every run records its API calls. The whole stack runs on one small instance for about 21 dollars a month.</a:t>
-            </a:r>
-            <a:endParaRPr lang="en-US" dirty="0"/>
+              <a:t>Cost optimisation is ten percent of the marks, so two angles. For the clouds we monitor: the recommendations engine compares each resource’s 30-day cost with its 7-day utilisation. On the demo data the biggest item is an idle GPU training VM. For our own platform: Cost Explorer charges a cent per request, so we never poll it every minute; the daily sync re-reads three days, today’s cost refreshes at most every six hours per Live connection, and every run records its API calls. That is about five requests a day, or a dollar fifty a month per AWS account. The whole stack runs on one small instance for about 21 dollars a month.</a:t>
+            </a:r>
           </a:p>
         </p:txBody>
       </p:sp>
@@ -963,10 +963,8 @@
           <a:lstStyle/>
           <a:p>
             <a:r>
-              <a:rPr lang="en-US" dirty="0"/>
-              <a:t>Before the viva: docker compose up, open the dashboard, the mock inbox at /mock-inbox/ and Prometheus alerts in separate tabs. For step 5 use Cloud Accounts, AWS, times 2.5, one day ago. Clear the spike afterwards to show resolved messages.</a:t>
-            </a:r>
-            <a:endParaRPr lang="en-US" dirty="0"/>
+              <a:t>Before the viva: docker compose up, open the dashboard, the mock inbox at /mock-inbox/ and Prometheus alerts in separate tabs. For step 5 use Cloud Accounts, AWS, times 2.5, one day ago. Clear the spike afterwards to show resolved messages. For step 6, show the form and a failed test only; never type real keys on a projected screen.</a:t>
+            </a:r>
           </a:p>
         </p:txBody>
       </p:sp>
@@ -1139,10 +1137,8 @@
           <a:lstStyle/>
           <a:p>
             <a:r>
-              <a:rPr lang="en-US" dirty="0"/>
-              <a:t>Likely questions: why PostgreSQL over MongoDB; why not Grafana; how GCP costs are fetched without a cost API; how duplicate alerts are avoided; what happens when a provider’s credentials are missing (that provider is skipped, the others continue).</a:t>
-            </a:r>
-            <a:endParaRPr lang="en-US" dirty="0"/>
+              <a:t>Likely questions: why PostgreSQL over MongoDB; why not Grafana; how GCP costs are fetched without a cost API; how duplicate alerts are avoided; what happens when a provider’s credentials are missing (that provider is skipped, the others continue); how credentials are protected; why mock and real data are kept separately.</a:t>
+            </a:r>
           </a:p>
         </p:txBody>
       </p:sp>
@@ -1175,6 +1171,146 @@
         <p14:creationId xmlns:p14="http://schemas.microsoft.com/office/powerpoint/2010/main" val="1024086991"/>
       </p:ext>
     </p:extLst>
+  </p:cSld>
+  <p:clrMapOvr>
+    <a:masterClrMapping/>
+  </p:clrMapOvr>
+</p:notes>
+</file>
+
+<file path=ppt/notesSlides/notesSlide17.xml><?xml version="1.0" encoding="utf-8"?>
+<p:notes xmlns:a="http://schemas.openxmlformats.org/drawingml/2006/main" xmlns:p="http://schemas.openxmlformats.org/presentationml/2006/main" xmlns:r="http://schemas.openxmlformats.org/officeDocument/2006/relationships">
+  <p:cSld>
+    <p:spTree>
+      <p:nvGrpSpPr>
+        <p:cNvPr id="1" name=""/>
+        <p:cNvGrpSpPr/>
+        <p:nvPr/>
+      </p:nvGrpSpPr>
+      <p:grpSpPr>
+        <a:xfrm>
+          <a:off x="0" y="0"/>
+          <a:ext cx="0" cy="0"/>
+          <a:chOff x="0" y="0"/>
+          <a:chExt cx="0" cy="0"/>
+        </a:xfrm>
+      </p:grpSpPr>
+      <p:sp>
+        <p:nvSpPr>
+          <p:cNvPr id="2" name="Slide Image Placeholder 1"/>
+          <p:cNvSpPr>
+            <a:spLocks noGrp="1"/>
+          </p:cNvSpPr>
+          <p:nvPr>
+            <p:ph type="sldImg" idx="2"/>
+          </p:nvPr>
+        </p:nvSpPr>
+        <p:spPr/>
+      </p:sp>
+      <p:sp>
+        <p:nvSpPr>
+          <p:cNvPr id="3" name="Notes Placeholder 2"/>
+          <p:cNvSpPr>
+            <a:spLocks noGrp="1"/>
+          </p:cNvSpPr>
+          <p:nvPr>
+            <p:ph type="body" idx="3" sz="quarter"/>
+          </p:nvPr>
+        </p:nvSpPr>
+        <p:spPr/>
+        <p:txBody>
+          <a:bodyPr/>
+          <a:lstStyle/>
+          <a:p>
+            <a:r>
+              <a:t>The brief asks for real cloud data, but a demo needs to run with no account, so every cloud starts on Mock and nothing about Live is kept in the env file. Going Live, each environment gets its own cloud account, and everything from that account appears under that environment on the Dashboard, Cost Explorer, Resources and Reports. Environments without a configuration show no data rather than mixing simulated figures into a Live cloud. Every row records whether it is mock or live, so switching is instant and loses nothing. Because totals can still combine a Live cloud with a Mock one, data screens label each cloud and warn. This screenshot uses simulated AWS accounts.</a:t>
+            </a:r>
+          </a:p>
+        </p:txBody>
+      </p:sp>
+      <p:sp>
+        <p:nvSpPr>
+          <p:cNvPr id="4" name="Slide Number Placeholder 3"/>
+          <p:cNvSpPr>
+            <a:spLocks noGrp="1"/>
+          </p:cNvSpPr>
+          <p:nvPr>
+            <p:ph type="sldNum" idx="5" sz="quarter"/>
+          </p:nvPr>
+        </p:nvSpPr>
+        <p:spPr/>
+      </p:sp>
+    </p:spTree>
+  </p:cSld>
+  <p:clrMapOvr>
+    <a:masterClrMapping/>
+  </p:clrMapOvr>
+</p:notes>
+</file>
+
+<file path=ppt/notesSlides/notesSlide18.xml><?xml version="1.0" encoding="utf-8"?>
+<p:notes xmlns:a="http://schemas.openxmlformats.org/drawingml/2006/main" xmlns:p="http://schemas.openxmlformats.org/presentationml/2006/main" xmlns:r="http://schemas.openxmlformats.org/officeDocument/2006/relationships">
+  <p:cSld>
+    <p:spTree>
+      <p:nvGrpSpPr>
+        <p:cNvPr id="1" name=""/>
+        <p:cNvGrpSpPr/>
+        <p:nvPr/>
+      </p:nvGrpSpPr>
+      <p:grpSpPr>
+        <a:xfrm>
+          <a:off x="0" y="0"/>
+          <a:ext cx="0" cy="0"/>
+          <a:chOff x="0" y="0"/>
+          <a:chExt cx="0" cy="0"/>
+        </a:xfrm>
+      </p:grpSpPr>
+      <p:sp>
+        <p:nvSpPr>
+          <p:cNvPr id="2" name="Slide Image Placeholder 1"/>
+          <p:cNvSpPr>
+            <a:spLocks noGrp="1"/>
+          </p:cNvSpPr>
+          <p:nvPr>
+            <p:ph type="sldImg" idx="2"/>
+          </p:nvPr>
+        </p:nvSpPr>
+        <p:spPr/>
+      </p:sp>
+      <p:sp>
+        <p:nvSpPr>
+          <p:cNvPr id="3" name="Notes Placeholder 2"/>
+          <p:cNvSpPr>
+            <a:spLocks noGrp="1"/>
+          </p:cNvSpPr>
+          <p:nvPr>
+            <p:ph type="body" idx="3" sz="quarter"/>
+          </p:nvPr>
+        </p:nvSpPr>
+        <p:spPr/>
+        <p:txBody>
+          <a:bodyPr/>
+          <a:lstStyle/>
+          <a:p>
+            <a:r>
+              <a:t>To connect a real account, an admin chooses the environment, fills in the form and clicks Test connection. Each permission is checked separately, so one test shows everything to fix, with a plain-language next step. The server stores a keyed hash of the values that passed, so it refuses to save or activate anything else, even if someone bypasses the screen. It also refuses an account already used by another environment, because its cost would count twice. Secrets are encrypted and the API never returns them. Testing covered two simulated AWS accounts plus a real rejected login at Microsoft; connecting a real account with real billing data still needs real credentials.</a:t>
+            </a:r>
+          </a:p>
+        </p:txBody>
+      </p:sp>
+      <p:sp>
+        <p:nvSpPr>
+          <p:cNvPr id="4" name="Slide Number Placeholder 3"/>
+          <p:cNvSpPr>
+            <a:spLocks noGrp="1"/>
+          </p:cNvSpPr>
+          <p:nvPr>
+            <p:ph type="sldNum" idx="5" sz="quarter"/>
+          </p:nvPr>
+        </p:nvSpPr>
+        <p:spPr/>
+      </p:sp>
+    </p:spTree>
   </p:cSld>
   <p:clrMapOvr>
     <a:masterClrMapping/>
@@ -1579,10 +1715,8 @@
           <a:lstStyle/>
           <a:p>
             <a:r>
-              <a:rPr lang="en-US" dirty="0"/>
-              <a:t>The key design decision: one grain for every provider, which is provider, account, day, service, environment, region and resource. Note that GCP’s Cloud Billing API does not return daily cost lines, so we read the BigQuery billing export, which is Google’s supported source. A DATA_SOURCE switch in .env flips between the mock generator and live APIs.</a:t>
-            </a:r>
-            <a:endParaRPr lang="en-US" dirty="0"/>
+              <a:t>The key design decision: one grain for every provider, which is provider, account, day, service, environment, region and resource. Note that GCP’s Cloud Billing API does not return daily cost lines, so we read the BigQuery billing export, which is Google’s supported source. Each cloud has a Mock or Live mode on the Cloud Accounts screen, and each Live connection sets the environment of everything it reads.</a:t>
+            </a:r>
           </a:p>
         </p:txBody>
       </p:sp>
@@ -1668,7 +1802,7 @@
           <a:p>
             <a:r>
               <a:rPr lang="en-US" dirty="0"/>
-              <a:t>This is the screen approved at the design stage. Filters for provider, environment, resource type and date range sit at the top and are shared with the other screens. Theme and currency toggles are in the header.</a:t>
+              <a:t>This is the screen approved at the design stage. Filters for provider, environment, resource type and date range sit at the top and are shared with the other screens. Theme and currency are set in Settings; the signed-in user and Logout stay at the top right of every screen.</a:t>
             </a:r>
             <a:endParaRPr lang="en-US" dirty="0"/>
           </a:p>
@@ -2877,6 +3011,850 @@
 
 <file path=ppt/slides/slide10.xml><?xml version="1.0" encoding="utf-8"?>
 <p:sld xmlns:a="http://schemas.openxmlformats.org/drawingml/2006/main" xmlns:r="http://schemas.openxmlformats.org/officeDocument/2006/relationships" xmlns:p="http://schemas.openxmlformats.org/presentationml/2006/main">
+  <p:cSld name="Slide 7">
+    <p:bg>
+      <p:bgPr>
+        <a:solidFill>
+          <a:srgbClr val="0B1220"/>
+        </a:solidFill>
+      </p:bgPr>
+    </p:bg>
+    <p:spTree>
+      <p:nvGrpSpPr>
+        <p:cNvPr id="1" name=""/>
+        <p:cNvGrpSpPr/>
+        <p:nvPr/>
+      </p:nvGrpSpPr>
+      <p:grpSpPr>
+        <a:xfrm>
+          <a:off x="0" y="0"/>
+          <a:ext cx="0" cy="0"/>
+          <a:chOff x="0" y="0"/>
+          <a:chExt cx="0" cy="0"/>
+        </a:xfrm>
+      </p:grpSpPr>
+      <p:sp>
+        <p:nvSpPr>
+          <p:cNvPr id="2" name="Text 0"/>
+          <p:cNvSpPr/>
+          <p:nvPr/>
+        </p:nvSpPr>
+        <p:spPr>
+          <a:xfrm>
+            <a:off x="812800" y="1271935"/>
+            <a:ext cx="3401060" cy="238720"/>
+          </a:xfrm>
+          <a:prstGeom prst="rect">
+            <a:avLst/>
+          </a:prstGeom>
+          <a:noFill/>
+          <a:ln/>
+        </p:spPr>
+        <p:txBody>
+          <a:bodyPr wrap="square" lIns="0" tIns="0" rIns="0" bIns="0" rtlCol="0" anchor="t">
+            <a:normAutofit/>
+          </a:bodyPr>
+          <a:lstStyle/>
+          <a:p>
+            <a:pPr algn="l" indent="0" marL="0">
+              <a:lnSpc>
+                <a:spcPts val="1680"/>
+              </a:lnSpc>
+              <a:buNone/>
+            </a:pPr>
+            <a:r>
+              <a:rPr lang="en-US" sz="1200" spc="150" kern="0" dirty="0">
+                <a:solidFill>
+                  <a:srgbClr val="5B9BFF"/>
+                </a:solidFill>
+                <a:latin typeface="JetBrains Mono" pitchFamily="49" charset="0"/>
+                <a:ea typeface="JetBrains Mono" pitchFamily="49" charset="-122"/>
+                <a:cs typeface="JetBrains Mono" pitchFamily="49" charset="-120"/>
+              </a:rPr>
+              <a:t>CONNECTING A REAL ACCOUNT</a:t>
+            </a:r>
+            <a:endParaRPr lang="en-US" sz="1200" dirty="0">
+              <a:latin typeface="JetBrains Mono" charset="0"/>
+              <a:ea typeface="JetBrains Mono" charset="0"/>
+              <a:cs typeface="JetBrains Mono" charset="0"/>
+            </a:endParaRPr>
+          </a:p>
+        </p:txBody>
+      </p:sp>
+      <p:sp>
+        <p:nvSpPr>
+          <p:cNvPr id="3" name="Text 1"/>
+          <p:cNvSpPr/>
+          <p:nvPr>
+            <p:ph type="title"/>
+          </p:nvPr>
+        </p:nvSpPr>
+        <p:spPr>
+          <a:xfrm>
+            <a:off x="812800" y="1663055"/>
+            <a:ext cx="3401060" cy="919460"/>
+          </a:xfrm>
+          <a:prstGeom prst="rect">
+            <a:avLst/>
+          </a:prstGeom>
+          <a:noFill/>
+          <a:ln/>
+        </p:spPr>
+        <p:txBody>
+          <a:bodyPr wrap="square" lIns="0" tIns="0" rIns="0" bIns="0" rtlCol="0" anchor="t">
+            <a:normAutofit/>
+          </a:bodyPr>
+          <a:lstStyle/>
+          <a:p>
+            <a:pPr algn="l" indent="0" marL="0">
+              <a:lnSpc>
+                <a:spcPts val="3520"/>
+              </a:lnSpc>
+              <a:buNone/>
+            </a:pPr>
+            <a:r>
+              <a:rPr lang="en-US" sz="3200" b="1" i="0" dirty="0">
+                <a:solidFill>
+                  <a:srgbClr val="E8ECF4"/>
+                </a:solidFill>
+                <a:latin typeface="IBM Plex Sans" pitchFamily="34" charset="0"/>
+                <a:ea typeface="IBM Plex Sans" pitchFamily="34" charset="-122"/>
+                <a:cs typeface="IBM Plex Sans" pitchFamily="34" charset="-120"/>
+              </a:rPr>
+              <a:t>Tested before it is trusted</a:t>
+            </a:r>
+            <a:endParaRPr lang="en-US" sz="3200" dirty="0">
+              <a:latin typeface="IBM Plex Sans" charset="0"/>
+              <a:ea typeface="IBM Plex Sans" charset="0"/>
+              <a:cs typeface="IBM Plex Sans" charset="0"/>
+            </a:endParaRPr>
+          </a:p>
+        </p:txBody>
+      </p:sp>
+      <p:sp>
+        <p:nvSpPr>
+          <p:cNvPr id="4" name="Text 2"/>
+          <p:cNvSpPr/>
+          <p:nvPr/>
+        </p:nvSpPr>
+        <p:spPr>
+          <a:xfrm>
+            <a:off x="883920" y="2734915"/>
+            <a:ext cx="3322320" cy="2597150"/>
+          </a:xfrm>
+          <a:prstGeom prst="rect">
+            <a:avLst/>
+          </a:prstGeom>
+          <a:noFill/>
+          <a:ln/>
+        </p:spPr>
+        <p:txBody>
+          <a:bodyPr wrap="square" lIns="0" tIns="0" rIns="0" bIns="0" rtlCol="0" anchor="t">
+            <a:normAutofit/>
+          </a:bodyPr>
+          <a:lstStyle/>
+          <a:p>
+            <a:pPr algn="l" marL="182880" indent="-182880">
+              <a:lnSpc>
+                <a:spcPts val="2250"/>
+              </a:lnSpc>
+              <a:buSzPct val="100000"/>
+              <a:buChar char="•"/>
+            </a:pPr>
+            <a:r>
+              <a:rPr lang="en-US" sz="1500" dirty="0">
+                <a:solidFill>
+                  <a:srgbClr val="C9D3E3"/>
+                </a:solidFill>
+                <a:latin typeface="IBM Plex Sans" pitchFamily="34" charset="0"/>
+                <a:ea typeface="IBM Plex Sans" pitchFamily="34" charset="-122"/>
+                <a:cs typeface="IBM Plex Sans" pitchFamily="34" charset="-120"/>
+              </a:rPr>
+              <a:t>Choose the environment this account serves</a:t>
+            </a:r>
+            <a:endParaRPr lang="en-US" sz="1500" dirty="0">
+              <a:latin typeface="IBM Plex Sans" charset="0"/>
+              <a:ea typeface="IBM Plex Sans" charset="0"/>
+              <a:cs typeface="IBM Plex Sans" charset="0"/>
+            </a:endParaRPr>
+          </a:p>
+          <a:p>
+            <a:pPr algn="l" marL="182880" indent="-182880">
+              <a:lnSpc>
+                <a:spcPts val="2250"/>
+              </a:lnSpc>
+              <a:buSzPct val="100000"/>
+              <a:buChar char="•"/>
+            </a:pPr>
+            <a:r>
+              <a:rPr lang="en-US" sz="1500" dirty="0">
+                <a:solidFill>
+                  <a:srgbClr val="C9D3E3"/>
+                </a:solidFill>
+                <a:latin typeface="IBM Plex Sans" pitchFamily="34" charset="0"/>
+                <a:ea typeface="IBM Plex Sans" pitchFamily="34" charset="-122"/>
+                <a:cs typeface="IBM Plex Sans" pitchFamily="34" charset="-120"/>
+              </a:rPr>
+              <a:t>Each permission tested; failures say what to fix</a:t>
+            </a:r>
+            <a:endParaRPr lang="en-US" sz="1500" dirty="0">
+              <a:latin typeface="IBM Plex Sans" charset="0"/>
+              <a:ea typeface="IBM Plex Sans" charset="0"/>
+              <a:cs typeface="IBM Plex Sans" charset="0"/>
+            </a:endParaRPr>
+          </a:p>
+          <a:p>
+            <a:pPr algn="l" marL="182880" indent="-182880">
+              <a:lnSpc>
+                <a:spcPts val="2250"/>
+              </a:lnSpc>
+              <a:buSzPct val="100000"/>
+              <a:buChar char="•"/>
+            </a:pPr>
+            <a:r>
+              <a:rPr lang="en-US" sz="1500" dirty="0">
+                <a:solidFill>
+                  <a:srgbClr val="C9D3E3"/>
+                </a:solidFill>
+                <a:latin typeface="IBM Plex Sans" pitchFamily="34" charset="0"/>
+                <a:ea typeface="IBM Plex Sans" pitchFamily="34" charset="-122"/>
+                <a:cs typeface="IBM Plex Sans" pitchFamily="34" charset="-120"/>
+              </a:rPr>
+              <a:t>Save stays off until these exact values pass</a:t>
+            </a:r>
+            <a:endParaRPr lang="en-US" sz="1500" dirty="0">
+              <a:latin typeface="IBM Plex Sans" charset="0"/>
+              <a:ea typeface="IBM Plex Sans" charset="0"/>
+              <a:cs typeface="IBM Plex Sans" charset="0"/>
+            </a:endParaRPr>
+          </a:p>
+          <a:p>
+            <a:pPr algn="l" marL="182880" indent="-182880">
+              <a:lnSpc>
+                <a:spcPts val="2250"/>
+              </a:lnSpc>
+              <a:buSzPct val="100000"/>
+              <a:buChar char="•"/>
+            </a:pPr>
+            <a:r>
+              <a:rPr lang="en-US" sz="1500" dirty="0">
+                <a:solidFill>
+                  <a:srgbClr val="C9D3E3"/>
+                </a:solidFill>
+                <a:latin typeface="IBM Plex Sans" pitchFamily="34" charset="0"/>
+                <a:ea typeface="IBM Plex Sans" pitchFamily="34" charset="-122"/>
+                <a:cs typeface="IBM Plex Sans" pitchFamily="34" charset="-120"/>
+              </a:rPr>
+              <a:t>An account used by another environment is refused</a:t>
+            </a:r>
+            <a:endParaRPr lang="en-US" sz="1500" dirty="0">
+              <a:latin typeface="IBM Plex Sans" charset="0"/>
+              <a:ea typeface="IBM Plex Sans" charset="0"/>
+              <a:cs typeface="IBM Plex Sans" charset="0"/>
+            </a:endParaRPr>
+          </a:p>
+          <a:p>
+            <a:pPr algn="l" marL="182880" indent="-182880">
+              <a:lnSpc>
+                <a:spcPts val="2250"/>
+              </a:lnSpc>
+              <a:buSzPct val="100000"/>
+              <a:buChar char="•"/>
+            </a:pPr>
+            <a:r>
+              <a:rPr lang="en-US" sz="1500" dirty="0">
+                <a:solidFill>
+                  <a:srgbClr val="C9D3E3"/>
+                </a:solidFill>
+                <a:latin typeface="IBM Plex Sans" pitchFamily="34" charset="0"/>
+                <a:ea typeface="IBM Plex Sans" pitchFamily="34" charset="-122"/>
+                <a:cs typeface="IBM Plex Sans" pitchFamily="34" charset="-120"/>
+              </a:rPr>
+              <a:t>Secrets encrypted, never shown again; admins only</a:t>
+            </a:r>
+            <a:endParaRPr lang="en-US" sz="1500" dirty="0">
+              <a:latin typeface="IBM Plex Sans" charset="0"/>
+              <a:ea typeface="IBM Plex Sans" charset="0"/>
+              <a:cs typeface="IBM Plex Sans" charset="0"/>
+            </a:endParaRPr>
+          </a:p>
+        </p:txBody>
+      </p:sp>
+      <p:pic>
+        <p:nvPicPr>
+          <p:cNvPr id="5" name="Image 0" descr="AWS configuration form after a passed test, with checks for sign-in, Cost Explorer, EC2, RDS and CloudWatch all passed">    </p:cNvPr>
+          <p:cNvPicPr>
+            <a:picLocks noChangeAspect="1"/>
+          </p:cNvPicPr>
+          <p:nvPr/>
+        </p:nvPicPr>
+        <p:blipFill>
+          <a:blip r:embed="rId3"/>
+          <a:stretch>
+            <a:fillRect/>
+          </a:stretch>
+        </p:blipFill>
+        <p:spPr>
+          <a:xfrm>
+            <a:off x="5955764" y="594360"/>
+            <a:ext cx="3724711" cy="5074920"/>
+          </a:xfrm>
+          <a:prstGeom prst="rect">
+            <a:avLst/>
+          </a:prstGeom>
+        </p:spPr>
+      </p:pic>
+      <p:sp>
+        <p:nvSpPr>
+          <p:cNvPr id="6" name="Shape 3"/>
+          <p:cNvSpPr/>
+          <p:nvPr/>
+        </p:nvSpPr>
+        <p:spPr>
+          <a:xfrm>
+            <a:off x="5852160" y="502920"/>
+            <a:ext cx="3931920" cy="5257800"/>
+          </a:xfrm>
+          <a:prstGeom prst="roundRect">
+            <a:avLst>
+              <a:gd name="adj" fmla="val 1847"/>
+            </a:avLst>
+          </a:prstGeom>
+          <a:noFill/>
+          <a:ln w="6350">
+            <a:solidFill>
+              <a:srgbClr val="243047"/>
+            </a:solidFill>
+            <a:prstDash val="solid"/>
+          </a:ln>
+        </p:spPr>
+        <p:txBody>
+          <a:bodyPr/>
+          <a:p/>
+        </p:txBody>
+      </p:sp>
+      <p:sp>
+        <p:nvSpPr>
+          <p:cNvPr id="7" name="Text 4"/>
+          <p:cNvSpPr/>
+          <p:nvPr/>
+        </p:nvSpPr>
+        <p:spPr>
+          <a:xfrm>
+            <a:off x="812800" y="6289080"/>
+            <a:ext cx="10883392" cy="238720"/>
+          </a:xfrm>
+          <a:prstGeom prst="rect">
+            <a:avLst/>
+          </a:prstGeom>
+          <a:noFill/>
+          <a:ln/>
+        </p:spPr>
+        <p:txBody>
+          <a:bodyPr wrap="square" lIns="0" tIns="0" rIns="0" bIns="0" rtlCol="0" anchor="t">
+            <a:normAutofit/>
+          </a:bodyPr>
+          <a:lstStyle/>
+          <a:p>
+            <a:pPr algn="l" indent="0" marL="0">
+              <a:lnSpc>
+                <a:spcPts val="1680"/>
+              </a:lnSpc>
+              <a:buNone/>
+            </a:pPr>
+            <a:r>
+              <a:rPr lang="en-US" sz="1200" dirty="0">
+                <a:solidFill>
+                  <a:srgbClr val="A9B4C8"/>
+                </a:solidFill>
+                <a:latin typeface="IBM Plex Sans" pitchFamily="34" charset="0"/>
+                <a:ea typeface="IBM Plex Sans" pitchFamily="34" charset="-122"/>
+                <a:cs typeface="IBM Plex Sans" pitchFamily="34" charset="-120"/>
+              </a:rPr>
+              <a:t>CloudLens · Capstone viva · 10</a:t>
+            </a:r>
+            <a:endParaRPr lang="en-US" sz="1200" dirty="0">
+              <a:latin typeface="IBM Plex Sans" charset="0"/>
+              <a:ea typeface="IBM Plex Sans" charset="0"/>
+              <a:cs typeface="IBM Plex Sans" charset="0"/>
+            </a:endParaRPr>
+          </a:p>
+        </p:txBody>
+      </p:sp>
+      <p:sp>
+        <p:nvSpPr>
+          <p:cNvPr id="7" name="Caption"/>
+          <p:cNvSpPr/>
+          <p:nvPr/>
+        </p:nvSpPr>
+        <p:spPr>
+          <a:xfrm>
+            <a:off x="5852160" y="5833872"/>
+            <a:ext cx="3931920" cy="238720"/>
+          </a:xfrm>
+          <a:prstGeom prst="rect">
+            <a:avLst/>
+          </a:prstGeom>
+          <a:noFill/>
+          <a:ln/>
+        </p:spPr>
+        <p:txBody>
+          <a:bodyPr wrap="square" lIns="0" tIns="0" rIns="0" bIns="0" rtlCol="0" anchor="t">
+            <a:normAutofit/>
+          </a:bodyPr>
+          <a:lstStyle/>
+          <a:p>
+            <a:pPr algn="l" indent="0" marL="0">
+              <a:lnSpc>
+                <a:spcPts val="1680"/>
+              </a:lnSpc>
+              <a:buNone/>
+            </a:pPr>
+            <a:r>
+              <a:rPr lang="en-US" sz="1200" dirty="0">
+                <a:solidFill>
+                  <a:srgbClr val="A9B4C8"/>
+                </a:solidFill>
+                <a:latin typeface="IBM Plex Sans" pitchFamily="34" charset="0"/>
+                <a:ea typeface="IBM Plex Sans" pitchFamily="34" charset="-122"/>
+                <a:cs typeface="IBM Plex Sans" pitchFamily="34" charset="-120"/>
+              </a:rPr>
+              <a:t>Simulated AWS service, made-up credentials</a:t>
+            </a:r>
+            <a:endParaRPr lang="en-US" sz="1200" dirty="0">
+              <a:latin typeface="IBM Plex Sans" charset="0"/>
+              <a:ea typeface="IBM Plex Sans" charset="0"/>
+              <a:cs typeface="IBM Plex Sans" charset="0"/>
+            </a:endParaRPr>
+          </a:p>
+        </p:txBody>
+      </p:sp>
+    </p:spTree>
+  </p:cSld>
+  <p:clrMapOvr>
+    <a:masterClrMapping/>
+  </p:clrMapOvr>
+</p:sld>
+</file>
+
+<file path=ppt/slides/slide11.xml><?xml version="1.0" encoding="utf-8"?>
+<p:sld xmlns:a="http://schemas.openxmlformats.org/drawingml/2006/main" xmlns:r="http://schemas.openxmlformats.org/officeDocument/2006/relationships" xmlns:p="http://schemas.openxmlformats.org/presentationml/2006/main">
+  <p:cSld name="Slide 9">
+    <p:bg>
+      <p:bgPr>
+        <a:solidFill>
+          <a:srgbClr val="FBFBF8"/>
+        </a:solidFill>
+      </p:bgPr>
+    </p:bg>
+    <p:spTree>
+      <p:nvGrpSpPr>
+        <p:cNvPr id="1" name=""/>
+        <p:cNvGrpSpPr/>
+        <p:nvPr/>
+      </p:nvGrpSpPr>
+      <p:grpSpPr>
+        <a:xfrm>
+          <a:off x="0" y="0"/>
+          <a:ext cx="0" cy="0"/>
+          <a:chOff x="0" y="0"/>
+          <a:chExt cx="0" cy="0"/>
+        </a:xfrm>
+      </p:grpSpPr>
+      <p:sp>
+        <p:nvSpPr>
+          <p:cNvPr id="2" name="Text 0"/>
+          <p:cNvSpPr/>
+          <p:nvPr/>
+        </p:nvSpPr>
+        <p:spPr>
+          <a:xfrm>
+            <a:off x="812800" y="812800"/>
+            <a:ext cx="10883392" cy="238720"/>
+          </a:xfrm>
+          <a:prstGeom prst="rect">
+            <a:avLst/>
+          </a:prstGeom>
+          <a:noFill/>
+          <a:ln/>
+        </p:spPr>
+        <p:txBody>
+          <a:bodyPr wrap="square" lIns="0" tIns="0" rIns="0" bIns="0" rtlCol="0" anchor="t">
+            <a:normAutofit/>
+          </a:bodyPr>
+          <a:lstStyle/>
+          <a:p>
+            <a:pPr algn="l" indent="0" marL="0">
+              <a:lnSpc>
+                <a:spcPts val="1680"/>
+              </a:lnSpc>
+              <a:buNone/>
+            </a:pPr>
+            <a:r>
+              <a:rPr lang="en-US" sz="1200" spc="150" kern="0" dirty="0">
+                <a:solidFill>
+                  <a:srgbClr val="1D5FD6"/>
+                </a:solidFill>
+                <a:latin typeface="JetBrains Mono" pitchFamily="49" charset="0"/>
+                <a:ea typeface="JetBrains Mono" pitchFamily="49" charset="-122"/>
+                <a:cs typeface="JetBrains Mono" pitchFamily="49" charset="-120"/>
+              </a:rPr>
+              <a:t>ALERTING PIPELINE</a:t>
+            </a:r>
+            <a:endParaRPr lang="en-US" sz="1200" dirty="0">
+              <a:latin typeface="JetBrains Mono" charset="0"/>
+              <a:ea typeface="JetBrains Mono" charset="0"/>
+              <a:cs typeface="JetBrains Mono" charset="0"/>
+            </a:endParaRPr>
+          </a:p>
+        </p:txBody>
+      </p:sp>
+      <p:sp>
+        <p:nvSpPr>
+          <p:cNvPr id="3" name="Text 1"/>
+          <p:cNvSpPr/>
+          <p:nvPr>
+            <p:ph type="title"/>
+          </p:nvPr>
+        </p:nvSpPr>
+        <p:spPr>
+          <a:xfrm>
+            <a:off x="812800" y="1127720"/>
+            <a:ext cx="10883392" cy="528290"/>
+          </a:xfrm>
+          <a:prstGeom prst="rect">
+            <a:avLst/>
+          </a:prstGeom>
+          <a:noFill/>
+          <a:ln/>
+        </p:spPr>
+        <p:txBody>
+          <a:bodyPr wrap="square" lIns="0" tIns="0" rIns="0" bIns="0" rtlCol="0" anchor="t">
+            <a:normAutofit/>
+          </a:bodyPr>
+          <a:lstStyle/>
+          <a:p>
+            <a:pPr algn="l" indent="0" marL="0">
+              <a:lnSpc>
+                <a:spcPts val="3960"/>
+              </a:lnSpc>
+              <a:buNone/>
+            </a:pPr>
+            <a:r>
+              <a:rPr lang="en-US" sz="3600" b="1" i="0" dirty="0">
+                <a:solidFill>
+                  <a:srgbClr val="0F172A"/>
+                </a:solidFill>
+                <a:latin typeface="IBM Plex Sans" pitchFamily="34" charset="0"/>
+                <a:ea typeface="IBM Plex Sans" pitchFamily="34" charset="-122"/>
+                <a:cs typeface="IBM Plex Sans" pitchFamily="34" charset="-120"/>
+              </a:rPr>
+              <a:t>Rules in the UI, delivery by Prometheus</a:t>
+            </a:r>
+            <a:endParaRPr lang="en-US" sz="3600" dirty="0">
+              <a:latin typeface="IBM Plex Sans" charset="0"/>
+              <a:ea typeface="IBM Plex Sans" charset="0"/>
+              <a:cs typeface="IBM Plex Sans" charset="0"/>
+            </a:endParaRPr>
+          </a:p>
+        </p:txBody>
+      </p:sp>
+      <p:pic>
+        <p:nvPicPr>
+          <p:cNvPr id="4" name="Image 0" descr="Alert flow: rule defined in UI, alert engine sets a gauge, Prometheus fires, Alertmanager groups and routes, webhook stores the event, Slack and Microsoft Teams receive messages">    </p:cNvPr>
+          <p:cNvPicPr>
+            <a:picLocks noChangeAspect="1"/>
+          </p:cNvPicPr>
+          <p:nvPr/>
+        </p:nvPicPr>
+        <p:blipFill>
+          <a:blip r:embed="rId1"/>
+          <a:srcRect l="-6523" r="-6523" t="0" b="0"/>
+          <a:stretch/>
+        </p:blipFill>
+        <p:spPr>
+          <a:xfrm>
+            <a:off x="812800" y="1884611"/>
+            <a:ext cx="10566400" cy="2349500"/>
+          </a:xfrm>
+          <a:prstGeom prst="rect">
+            <a:avLst/>
+          </a:prstGeom>
+        </p:spPr>
+      </p:pic>
+      <p:sp>
+        <p:nvSpPr>
+          <p:cNvPr id="5" name="Text 2"/>
+          <p:cNvSpPr/>
+          <p:nvPr/>
+        </p:nvSpPr>
+        <p:spPr>
+          <a:xfrm>
+            <a:off x="815975" y="4491286"/>
+            <a:ext cx="3414167" cy="808930"/>
+          </a:xfrm>
+          <a:prstGeom prst="roundRect">
+            <a:avLst>
+              <a:gd name="adj" fmla="val 12167"/>
+            </a:avLst>
+          </a:prstGeom>
+          <a:solidFill>
+            <a:srgbClr val="FFFFFF"/>
+          </a:solidFill>
+          <a:ln w="6350">
+            <a:solidFill>
+              <a:srgbClr val="DCE2EB"/>
+            </a:solidFill>
+            <a:prstDash val="solid"/>
+          </a:ln>
+        </p:spPr>
+        <p:txBody>
+          <a:bodyPr wrap="square" lIns="152147" tIns="126747" rIns="60581" bIns="101347" rtlCol="0" anchor="t">
+            <a:normAutofit/>
+          </a:bodyPr>
+          <a:lstStyle/>
+          <a:p>
+            <a:pPr algn="l" indent="0" marL="0">
+              <a:lnSpc>
+                <a:spcPts val="1960"/>
+              </a:lnSpc>
+              <a:buNone/>
+            </a:pPr>
+            <a:r>
+              <a:rPr lang="en-US" sz="1400" dirty="0">
+                <a:solidFill>
+                  <a:srgbClr val="0F172A"/>
+                </a:solidFill>
+                <a:latin typeface="IBM Plex Sans" pitchFamily="34" charset="0"/>
+                <a:ea typeface="IBM Plex Sans" pitchFamily="34" charset="-122"/>
+                <a:cs typeface="IBM Plex Sans" pitchFamily="34" charset="-120"/>
+              </a:rPr>
+              <a:t>One gauge per rule: </a:t>
+            </a:r>
+            <a:r>
+              <a:rPr lang="en-US" sz="1400" b="1" dirty="0">
+                <a:solidFill>
+                  <a:srgbClr val="0F172A"/>
+                </a:solidFill>
+                <a:latin typeface="IBM Plex Sans" pitchFamily="34" charset="0"/>
+                <a:ea typeface="IBM Plex Sans" pitchFamily="34" charset="-122"/>
+                <a:cs typeface="IBM Plex Sans" pitchFamily="34" charset="-120"/>
+              </a:rPr>
+              <a:t>cloudlens_alert_rule_breached</a:t>
+            </a:r>
+            <a:endParaRPr lang="en-US" sz="1400" dirty="0">
+              <a:latin typeface="IBM Plex Sans" charset="0"/>
+              <a:ea typeface="IBM Plex Sans" charset="0"/>
+              <a:cs typeface="IBM Plex Sans" charset="0"/>
+            </a:endParaRPr>
+          </a:p>
+        </p:txBody>
+      </p:sp>
+      <p:sp>
+        <p:nvSpPr>
+          <p:cNvPr id="6" name="Text 3"/>
+          <p:cNvSpPr/>
+          <p:nvPr/>
+        </p:nvSpPr>
+        <p:spPr>
+          <a:xfrm>
+            <a:off x="4388892" y="4491286"/>
+            <a:ext cx="3414216" cy="808930"/>
+          </a:xfrm>
+          <a:prstGeom prst="roundRect">
+            <a:avLst>
+              <a:gd name="adj" fmla="val 12167"/>
+            </a:avLst>
+          </a:prstGeom>
+          <a:solidFill>
+            <a:srgbClr val="FFFFFF"/>
+          </a:solidFill>
+          <a:ln w="6350">
+            <a:solidFill>
+              <a:srgbClr val="DCE2EB"/>
+            </a:solidFill>
+            <a:prstDash val="solid"/>
+          </a:ln>
+        </p:spPr>
+        <p:txBody>
+          <a:bodyPr wrap="square" lIns="152147" tIns="126747" rIns="60579" bIns="101347" rtlCol="0" anchor="t">
+            <a:normAutofit/>
+          </a:bodyPr>
+          <a:lstStyle/>
+          <a:p>
+            <a:pPr algn="l" indent="0" marL="0">
+              <a:lnSpc>
+                <a:spcPts val="1960"/>
+              </a:lnSpc>
+              <a:buNone/>
+            </a:pPr>
+            <a:r>
+              <a:rPr lang="en-US" sz="1400" dirty="0">
+                <a:solidFill>
+                  <a:srgbClr val="0F172A"/>
+                </a:solidFill>
+                <a:latin typeface="IBM Plex Sans" pitchFamily="34" charset="0"/>
+                <a:ea typeface="IBM Plex Sans" pitchFamily="34" charset="-122"/>
+                <a:cs typeface="IBM Plex Sans" pitchFamily="34" charset="-120"/>
+              </a:rPr>
+              <a:t>Grouping, dedupe, 4 h repeat, </a:t>
+            </a:r>
+            <a:r>
+              <a:rPr lang="en-US" sz="1400" b="1" dirty="0">
+                <a:solidFill>
+                  <a:srgbClr val="0F172A"/>
+                </a:solidFill>
+                <a:latin typeface="IBM Plex Sans" pitchFamily="34" charset="0"/>
+                <a:ea typeface="IBM Plex Sans" pitchFamily="34" charset="-122"/>
+                <a:cs typeface="IBM Plex Sans" pitchFamily="34" charset="-120"/>
+              </a:rPr>
+              <a:t>resolved</a:t>
+            </a:r>
+            <a:r>
+              <a:rPr lang="en-US" sz="1400" dirty="0">
+                <a:solidFill>
+                  <a:srgbClr val="0F172A"/>
+                </a:solidFill>
+                <a:latin typeface="IBM Plex Sans" pitchFamily="34" charset="0"/>
+                <a:ea typeface="IBM Plex Sans" pitchFamily="34" charset="-122"/>
+                <a:cs typeface="IBM Plex Sans" pitchFamily="34" charset="-120"/>
+              </a:rPr>
+              <a:t> messages</a:t>
+            </a:r>
+            <a:endParaRPr lang="en-US" sz="1400" dirty="0">
+              <a:latin typeface="IBM Plex Sans" charset="0"/>
+              <a:ea typeface="IBM Plex Sans" charset="0"/>
+              <a:cs typeface="IBM Plex Sans" charset="0"/>
+            </a:endParaRPr>
+          </a:p>
+        </p:txBody>
+      </p:sp>
+      <p:sp>
+        <p:nvSpPr>
+          <p:cNvPr id="7" name="Text 4"/>
+          <p:cNvSpPr/>
+          <p:nvPr/>
+        </p:nvSpPr>
+        <p:spPr>
+          <a:xfrm>
+            <a:off x="7961858" y="4491286"/>
+            <a:ext cx="3414167" cy="808930"/>
+          </a:xfrm>
+          <a:prstGeom prst="roundRect">
+            <a:avLst>
+              <a:gd name="adj" fmla="val 12167"/>
+            </a:avLst>
+          </a:prstGeom>
+          <a:solidFill>
+            <a:srgbClr val="FFFFFF"/>
+          </a:solidFill>
+          <a:ln w="6350">
+            <a:solidFill>
+              <a:srgbClr val="DCE2EB"/>
+            </a:solidFill>
+            <a:prstDash val="solid"/>
+          </a:ln>
+        </p:spPr>
+        <p:txBody>
+          <a:bodyPr wrap="none" lIns="0" tIns="126747" rIns="0" bIns="101347" rtlCol="0" anchor="t">
+            <a:normAutofit/>
+          </a:bodyPr>
+          <a:lstStyle/>
+          <a:p>
+            <a:pPr algn="ctr" indent="0" marL="0">
+              <a:lnSpc>
+                <a:spcPts val="1960"/>
+              </a:lnSpc>
+              <a:buNone/>
+            </a:pPr>
+            <a:r>
+              <a:rPr lang="en-US" sz="1400" dirty="0">
+                <a:solidFill>
+                  <a:srgbClr val="0F172A"/>
+                </a:solidFill>
+                <a:latin typeface="IBM Plex Sans" pitchFamily="34" charset="0"/>
+                <a:ea typeface="IBM Plex Sans" pitchFamily="34" charset="-122"/>
+                <a:cs typeface="IBM Plex Sans" pitchFamily="34" charset="-120"/>
+              </a:rPr>
+              <a:t>Webhook protected by a </a:t>
+            </a:r>
+            <a:r>
+              <a:rPr lang="en-US" sz="1400" b="1" dirty="0">
+                <a:solidFill>
+                  <a:srgbClr val="0F172A"/>
+                </a:solidFill>
+                <a:latin typeface="IBM Plex Sans" pitchFamily="34" charset="0"/>
+                <a:ea typeface="IBM Plex Sans" pitchFamily="34" charset="-122"/>
+                <a:cs typeface="IBM Plex Sans" pitchFamily="34" charset="-120"/>
+              </a:rPr>
+              <a:t>bearer token</a:t>
+            </a:r>
+            <a:endParaRPr lang="en-US" sz="1400" dirty="0">
+              <a:latin typeface="IBM Plex Sans" charset="0"/>
+              <a:ea typeface="IBM Plex Sans" charset="0"/>
+              <a:cs typeface="IBM Plex Sans" charset="0"/>
+            </a:endParaRPr>
+          </a:p>
+        </p:txBody>
+      </p:sp>
+      <p:sp>
+        <p:nvSpPr>
+          <p:cNvPr id="8" name="Text 5"/>
+          <p:cNvSpPr/>
+          <p:nvPr/>
+        </p:nvSpPr>
+        <p:spPr>
+          <a:xfrm>
+            <a:off x="812800" y="6238280"/>
+            <a:ext cx="10883392" cy="238720"/>
+          </a:xfrm>
+          <a:prstGeom prst="rect">
+            <a:avLst/>
+          </a:prstGeom>
+          <a:noFill/>
+          <a:ln/>
+        </p:spPr>
+        <p:txBody>
+          <a:bodyPr wrap="square" lIns="0" tIns="0" rIns="0" bIns="0" rtlCol="0" anchor="t">
+            <a:normAutofit/>
+          </a:bodyPr>
+          <a:lstStyle/>
+          <a:p>
+            <a:pPr algn="l" indent="0" marL="0">
+              <a:lnSpc>
+                <a:spcPts val="1680"/>
+              </a:lnSpc>
+              <a:buNone/>
+            </a:pPr>
+            <a:r>
+              <a:rPr lang="en-US" sz="1200" dirty="0">
+                <a:solidFill>
+                  <a:srgbClr val="4A5468"/>
+                </a:solidFill>
+                <a:latin typeface="IBM Plex Sans" pitchFamily="34" charset="0"/>
+                <a:ea typeface="IBM Plex Sans" pitchFamily="34" charset="-122"/>
+                <a:cs typeface="IBM Plex Sans" pitchFamily="34" charset="-120"/>
+              </a:rPr>
+              <a:t>CloudLens · Capstone viva · 11</a:t>
+            </a:r>
+            <a:endParaRPr lang="en-US" sz="1200" dirty="0">
+              <a:latin typeface="IBM Plex Sans" charset="0"/>
+              <a:ea typeface="IBM Plex Sans" charset="0"/>
+              <a:cs typeface="IBM Plex Sans" charset="0"/>
+            </a:endParaRPr>
+          </a:p>
+        </p:txBody>
+      </p:sp>
+    </p:spTree>
+  </p:cSld>
+  <p:clrMapOvr>
+    <a:masterClrMapping/>
+  </p:clrMapOvr>
+</p:sld>
+</file>
+
+<file path=ppt/slides/slide12.xml><?xml version="1.0" encoding="utf-8"?>
+<p:sld xmlns:a="http://schemas.openxmlformats.org/drawingml/2006/main" xmlns:r="http://schemas.openxmlformats.org/officeDocument/2006/relationships" xmlns:p="http://schemas.openxmlformats.org/presentationml/2006/main">
   <p:cSld name="Slide 10">
     <p:bg>
       <p:bgPr>
@@ -4008,7 +4986,7 @@
           <p:nvPr/>
         </p:nvPicPr>
         <p:blipFill>
-          <a:blip r:embed="rId1"/>
+          <a:blip r:embed="rId4"/>
           <a:stretch>
             <a:fillRect/>
           </a:stretch>
@@ -4047,6 +5025,10 @@
             <a:prstDash val="solid"/>
           </a:ln>
         </p:spPr>
+        <p:txBody>
+          <a:bodyPr/>
+          <a:p/>
+        </p:txBody>
       </p:sp>
       <p:sp>
         <p:nvSpPr>
@@ -4086,7 +5068,7 @@
                 <a:ea typeface="IBM Plex Sans" pitchFamily="34" charset="-122"/>
                 <a:cs typeface="IBM Plex Sans" pitchFamily="34" charset="-120"/>
               </a:rPr>
-              <a:t>CloudLens · Capstone viva · 10</a:t>
+              <a:t>CloudLens · Capstone viva · 12</a:t>
             </a:r>
             <a:endParaRPr lang="en-US" sz="1200" dirty="0">
               <a:latin typeface="IBM Plex Sans" charset="0"/>
@@ -4104,7 +5086,7 @@
 </p:sld>
 </file>
 
-<file path=ppt/slides/slide11.xml><?xml version="1.0" encoding="utf-8"?>
+<file path=ppt/slides/slide13.xml><?xml version="1.0" encoding="utf-8"?>
 <p:sld xmlns:a="http://schemas.openxmlformats.org/drawingml/2006/main" xmlns:r="http://schemas.openxmlformats.org/officeDocument/2006/relationships" xmlns:p="http://schemas.openxmlformats.org/presentationml/2006/main">
   <p:cSld name="Slide 11">
     <p:bg>
@@ -4247,6 +5229,10 @@
           </a:solidFill>
           <a:ln/>
         </p:spPr>
+        <p:txBody>
+          <a:bodyPr/>
+          <a:p/>
+        </p:txBody>
       </p:sp>
       <p:sp>
         <p:nvSpPr>
@@ -4365,6 +5351,10 @@
           </a:solidFill>
           <a:ln/>
         </p:spPr>
+        <p:txBody>
+          <a:bodyPr/>
+          <a:p/>
+        </p:txBody>
       </p:sp>
       <p:sp>
         <p:nvSpPr>
@@ -4404,7 +5394,7 @@
                 <a:ea typeface="JetBrains Mono" pitchFamily="49" charset="-122"/>
                 <a:cs typeface="JetBrains Mono" pitchFamily="49" charset="-120"/>
               </a:rPr>
-              <a:t>$0.60</a:t>
+              <a:t>~$1.50</a:t>
             </a:r>
             <a:endParaRPr lang="en-US" sz="4800" dirty="0">
               <a:latin typeface="JetBrains Mono" charset="0"/>
@@ -4452,7 +5442,7 @@
                 <a:ea typeface="IBM Plex Sans" pitchFamily="34" charset="-122"/>
                 <a:cs typeface="IBM Plex Sans" pitchFamily="34" charset="-120"/>
               </a:rPr>
-              <a:t>per month in Cost Explorer calls: 3-day lookback, calls counted per sync</a:t>
+              <a:t>per month per AWS account in Cost Explorer calls: 3-day lookback, today refreshed every 6 h</a:t>
             </a:r>
             <a:endParaRPr lang="en-US" sz="1500" dirty="0">
               <a:latin typeface="IBM Plex Sans" charset="0"/>
@@ -4483,6 +5473,10 @@
           </a:solidFill>
           <a:ln/>
         </p:spPr>
+        <p:txBody>
+          <a:bodyPr/>
+          <a:p/>
+        </p:txBody>
       </p:sp>
       <p:sp>
         <p:nvSpPr>
@@ -4666,7 +5660,7 @@
                 <a:ea typeface="IBM Plex Sans" pitchFamily="34" charset="-122"/>
                 <a:cs typeface="IBM Plex Sans" pitchFamily="34" charset="-120"/>
               </a:rPr>
-              <a:t>CloudLens · Capstone viva · 11</a:t>
+              <a:t>CloudLens · Capstone viva · 13</a:t>
             </a:r>
             <a:endParaRPr lang="en-US" sz="1200" dirty="0">
               <a:latin typeface="IBM Plex Sans" charset="0"/>
@@ -4684,7 +5678,7 @@
 </p:sld>
 </file>
 
-<file path=ppt/slides/slide12.xml><?xml version="1.0" encoding="utf-8"?>
+<file path=ppt/slides/slide14.xml><?xml version="1.0" encoding="utf-8"?>
 <p:sld xmlns:a="http://schemas.openxmlformats.org/drawingml/2006/main" xmlns:r="http://schemas.openxmlformats.org/officeDocument/2006/relationships" xmlns:p="http://schemas.openxmlformats.org/presentationml/2006/main">
   <p:cSld name="Slide 12">
     <p:bg>
@@ -4832,6 +5826,10 @@
             <a:prstDash val="solid"/>
           </a:ln>
         </p:spPr>
+        <p:txBody>
+          <a:bodyPr/>
+          <a:p/>
+        </p:txBody>
       </p:sp>
       <p:sp>
         <p:nvSpPr>
@@ -4871,7 +5869,7 @@
                 <a:ea typeface="JetBrains Mono" pitchFamily="49" charset="-122"/>
                 <a:cs typeface="JetBrains Mono" pitchFamily="49" charset="-120"/>
               </a:rPr>
-              <a:t>84</a:t>
+              <a:t>144</a:t>
             </a:r>
             <a:endParaRPr lang="en-US" sz="4000" dirty="0">
               <a:latin typeface="JetBrains Mono" charset="0"/>
@@ -4955,6 +5953,10 @@
             <a:prstDash val="solid"/>
           </a:ln>
         </p:spPr>
+        <p:txBody>
+          <a:bodyPr/>
+          <a:p/>
+        </p:txBody>
       </p:sp>
       <p:sp>
         <p:nvSpPr>
@@ -5078,6 +6080,10 @@
             <a:prstDash val="solid"/>
           </a:ln>
         </p:spPr>
+        <p:txBody>
+          <a:bodyPr/>
+          <a:p/>
+        </p:txBody>
       </p:sp>
       <p:sp>
         <p:nvSpPr>
@@ -5117,7 +6123,7 @@
                 <a:ea typeface="JetBrains Mono" pitchFamily="49" charset="-122"/>
                 <a:cs typeface="JetBrains Mono" pitchFamily="49" charset="-120"/>
               </a:rPr>
-              <a:t>31</a:t>
+              <a:t>44</a:t>
             </a:r>
             <a:endParaRPr lang="en-US" sz="4000" dirty="0">
               <a:latin typeface="JetBrains Mono" charset="0"/>
@@ -5165,7 +6171,7 @@
                 <a:ea typeface="IBM Plex Sans" pitchFamily="34" charset="-122"/>
                 <a:cs typeface="IBM Plex Sans" pitchFamily="34" charset="-120"/>
               </a:rPr>
-              <a:t>frontend unit tests, incl. date picker</a:t>
+              <a:t>frontend unit tests, incl. date picker and config form</a:t>
             </a:r>
             <a:endParaRPr lang="en-US" sz="1400" dirty="0">
               <a:latin typeface="IBM Plex Sans" charset="0"/>
@@ -5201,6 +6207,10 @@
             <a:prstDash val="solid"/>
           </a:ln>
         </p:spPr>
+        <p:txBody>
+          <a:bodyPr/>
+          <a:p/>
+        </p:txBody>
       </p:sp>
       <p:sp>
         <p:nvSpPr>
@@ -5412,7 +6422,7 @@
                 <a:ea typeface="IBM Plex Sans" pitchFamily="34" charset="-122"/>
                 <a:cs typeface="IBM Plex Sans" pitchFamily="34" charset="-120"/>
               </a:rPr>
-              <a:t>Every screen captured in both themes and at phone width</a:t>
+              <a:t>Every screen in a real browser: 131 checks pass</a:t>
             </a:r>
             <a:endParaRPr lang="en-US" sz="1500" dirty="0">
               <a:latin typeface="IBM Plex Sans" charset="0"/>
@@ -5460,7 +6470,7 @@
                 <a:ea typeface="IBM Plex Sans" pitchFamily="34" charset="-122"/>
                 <a:cs typeface="IBM Plex Sans" pitchFamily="34" charset="-120"/>
               </a:rPr>
-              <a:t>CloudLens · Capstone viva · 12</a:t>
+              <a:t>CloudLens · Capstone viva · 14</a:t>
             </a:r>
             <a:endParaRPr lang="en-US" sz="1200" dirty="0">
               <a:latin typeface="IBM Plex Sans" charset="0"/>
@@ -5478,7 +6488,7 @@
 </p:sld>
 </file>
 
-<file path=ppt/slides/slide13.xml><?xml version="1.0" encoding="utf-8"?>
+<file path=ppt/slides/slide15.xml><?xml version="1.0" encoding="utf-8"?>
 <p:sld xmlns:a="http://schemas.openxmlformats.org/drawingml/2006/main" xmlns:r="http://schemas.openxmlformats.org/officeDocument/2006/relationships" xmlns:p="http://schemas.openxmlformats.org/presentationml/2006/main">
   <p:cSld name="Slide 13">
     <p:bg>
@@ -5621,6 +6631,10 @@
           </a:solidFill>
           <a:ln/>
         </p:spPr>
+        <p:txBody>
+          <a:bodyPr/>
+          <a:p/>
+        </p:txBody>
       </p:sp>
       <p:sp>
         <p:nvSpPr>
@@ -6001,7 +7015,7 @@
                 <a:ea typeface="IBM Plex Sans" pitchFamily="34" charset="-122"/>
                 <a:cs typeface="IBM Plex Sans" pitchFamily="34" charset="-120"/>
               </a:rPr>
-              <a:t>CloudLens · Capstone viva · 13</a:t>
+              <a:t>CloudLens · Capstone viva · 15</a:t>
             </a:r>
             <a:endParaRPr lang="en-US" sz="1200" dirty="0">
               <a:latin typeface="IBM Plex Sans" charset="0"/>
@@ -6019,7 +7033,7 @@
 </p:sld>
 </file>
 
-<file path=ppt/slides/slide14.xml><?xml version="1.0" encoding="utf-8"?>
+<file path=ppt/slides/slide16.xml><?xml version="1.0" encoding="utf-8"?>
 <p:sld xmlns:a="http://schemas.openxmlformats.org/drawingml/2006/main" xmlns:r="http://schemas.openxmlformats.org/officeDocument/2006/relationships" xmlns:p="http://schemas.openxmlformats.org/presentationml/2006/main">
   <p:cSld name="Slide 14">
     <p:bg>
@@ -6157,7 +7171,7 @@
         </p:nvGraphicFramePr>
         <p:xfrm>
           <a:off x="825500" y="1922711"/>
-          <a:ext cx="10553700" cy="2702074"/>
+          <a:ext cx="10553700" cy="3088088"/>
         </p:xfrm>
         <a:graphic>
           <a:graphicData uri="http://schemas.openxmlformats.org/drawingml/2006/table">
@@ -6678,7 +7692,7 @@
                           <a:ea typeface="IBM Plex Sans" pitchFamily="34" charset="-122"/>
                           <a:cs typeface="IBM Plex Sans" pitchFamily="34" charset="-120"/>
                         </a:rPr>
-                        <a:t>Toggle INR and light mode</a:t>
+                        <a:t>Settings: choose INR and Light</a:t>
                       </a:r>
                       <a:endParaRPr lang="en-US" sz="1400" dirty="0">
                         <a:latin typeface="IBM Plex Sans" charset="0"/>
@@ -7502,6 +8516,212 @@
                           <a:ea typeface="IBM Plex Sans" pitchFamily="34" charset="-122"/>
                           <a:cs typeface="IBM Plex Sans" pitchFamily="34" charset="-120"/>
                         </a:rPr>
+                        <a:t>Cloud Accounts: choose Live for AWS</a:t>
+                      </a:r>
+                      <a:endParaRPr lang="en-US" sz="1400" dirty="0">
+                        <a:latin typeface="IBM Plex Sans" charset="0"/>
+                        <a:ea typeface="IBM Plex Sans" charset="0"/>
+                        <a:cs typeface="IBM Plex Sans" charset="0"/>
+                      </a:endParaRPr>
+                    </a:p>
+                  </a:txBody>
+                  <a:tcPr marL="62230" marR="62230" marT="62230" marB="62230" anchor="t">
+                    <a:lnL w="12700" cap="flat" cmpd="sng" algn="ctr">
+                      <a:solidFill>
+                        <a:srgbClr val="40454F"/>
+                      </a:solidFill>
+                      <a:prstDash val="solid"/>
+                      <a:round/>
+                      <a:headEnd type="none" w="med" len="med"/>
+                      <a:tailEnd type="none" w="med" len="med"/>
+                    </a:lnL>
+                    <a:lnR w="12700" cap="flat" cmpd="sng" algn="ctr">
+                      <a:solidFill>
+                        <a:srgbClr val="40454F"/>
+                      </a:solidFill>
+                      <a:prstDash val="solid"/>
+                      <a:round/>
+                      <a:headEnd type="none" w="med" len="med"/>
+                      <a:tailEnd type="none" w="med" len="med"/>
+                    </a:lnR>
+                    <a:lnT w="12700" cap="flat" cmpd="sng" algn="ctr">
+                      <a:solidFill>
+                        <a:srgbClr val="40454F"/>
+                      </a:solidFill>
+                      <a:prstDash val="solid"/>
+                      <a:round/>
+                      <a:headEnd type="none" w="med" len="med"/>
+                      <a:tailEnd type="none" w="med" len="med"/>
+                    </a:lnT>
+                    <a:lnB w="12700" cap="flat" cmpd="sng" algn="ctr">
+                      <a:solidFill>
+                        <a:srgbClr val="40454F"/>
+                      </a:solidFill>
+                      <a:prstDash val="solid"/>
+                      <a:round/>
+                      <a:headEnd type="none" w="med" len="med"/>
+                      <a:tailEnd type="none" w="med" len="med"/>
+                    </a:lnB>
+                  </a:tcPr>
+                </a:tc>
+                <a:tc>
+                  <a:txBody>
+                    <a:bodyPr/>
+                    <a:lstStyle/>
+                    <a:p>
+                      <a:pPr indent="0" marL="0">
+                        <a:lnSpc>
+                          <a:spcPts val="1960"/>
+                        </a:lnSpc>
+                        <a:buNone/>
+                      </a:pPr>
+                      <a:r>
+                        <a:rPr lang="en-US" sz="1400" dirty="0">
+                          <a:solidFill>
+                            <a:srgbClr val="E8ECF4"/>
+                          </a:solidFill>
+                          <a:latin typeface="IBM Plex Sans" pitchFamily="34" charset="0"/>
+                          <a:ea typeface="IBM Plex Sans" pitchFamily="34" charset="-122"/>
+                          <a:cs typeface="IBM Plex Sans" pitchFamily="34" charset="-120"/>
+                        </a:rPr>
+                        <a:t>Form asks for an environment; Save stays off until the test passes</a:t>
+                      </a:r>
+                      <a:endParaRPr lang="en-US" sz="1400" dirty="0">
+                        <a:latin typeface="IBM Plex Sans" charset="0"/>
+                        <a:ea typeface="IBM Plex Sans" charset="0"/>
+                        <a:cs typeface="IBM Plex Sans" charset="0"/>
+                      </a:endParaRPr>
+                    </a:p>
+                  </a:txBody>
+                  <a:tcPr marL="62230" marR="62230" marT="62230" marB="62230" anchor="t">
+                    <a:lnL w="12700" cap="flat" cmpd="sng" algn="ctr">
+                      <a:solidFill>
+                        <a:srgbClr val="40454F"/>
+                      </a:solidFill>
+                      <a:prstDash val="solid"/>
+                      <a:round/>
+                      <a:headEnd type="none" w="med" len="med"/>
+                      <a:tailEnd type="none" w="med" len="med"/>
+                    </a:lnL>
+                    <a:lnR w="12700" cap="flat" cmpd="sng" algn="ctr">
+                      <a:solidFill>
+                        <a:srgbClr val="40454F"/>
+                      </a:solidFill>
+                      <a:prstDash val="solid"/>
+                      <a:round/>
+                      <a:headEnd type="none" w="med" len="med"/>
+                      <a:tailEnd type="none" w="med" len="med"/>
+                    </a:lnR>
+                    <a:lnT w="12700" cap="flat" cmpd="sng" algn="ctr">
+                      <a:solidFill>
+                        <a:srgbClr val="40454F"/>
+                      </a:solidFill>
+                      <a:prstDash val="solid"/>
+                      <a:round/>
+                      <a:headEnd type="none" w="med" len="med"/>
+                      <a:tailEnd type="none" w="med" len="med"/>
+                    </a:lnT>
+                    <a:lnB w="12700" cap="flat" cmpd="sng" algn="ctr">
+                      <a:solidFill>
+                        <a:srgbClr val="40454F"/>
+                      </a:solidFill>
+                      <a:prstDash val="solid"/>
+                      <a:round/>
+                      <a:headEnd type="none" w="med" len="med"/>
+                      <a:tailEnd type="none" w="med" len="med"/>
+                    </a:lnB>
+                  </a:tcPr>
+                </a:tc>
+              </a:tr>
+              <a:tr h="386011">
+                <a:tc>
+                  <a:txBody>
+                    <a:bodyPr/>
+                    <a:lstStyle/>
+                    <a:p>
+                      <a:pPr indent="0" marL="0">
+                        <a:lnSpc>
+                          <a:spcPts val="1960"/>
+                        </a:lnSpc>
+                        <a:buNone/>
+                      </a:pPr>
+                      <a:r>
+                        <a:rPr lang="en-US" sz="1400" dirty="0">
+                          <a:solidFill>
+                            <a:srgbClr val="E8ECF4"/>
+                          </a:solidFill>
+                          <a:latin typeface="IBM Plex Sans" pitchFamily="34" charset="0"/>
+                          <a:ea typeface="IBM Plex Sans" pitchFamily="34" charset="-122"/>
+                          <a:cs typeface="IBM Plex Sans" pitchFamily="34" charset="-120"/>
+                        </a:rPr>
+                        <a:t>7</a:t>
+                      </a:r>
+                      <a:endParaRPr lang="en-US" sz="1400" dirty="0">
+                        <a:latin typeface="IBM Plex Sans" charset="0"/>
+                        <a:ea typeface="IBM Plex Sans" charset="0"/>
+                        <a:cs typeface="IBM Plex Sans" charset="0"/>
+                      </a:endParaRPr>
+                    </a:p>
+                  </a:txBody>
+                  <a:tcPr marL="62230" marR="62230" marT="62230" marB="62230" anchor="t">
+                    <a:lnL w="12700" cap="flat" cmpd="sng" algn="ctr">
+                      <a:solidFill>
+                        <a:srgbClr val="40454F"/>
+                      </a:solidFill>
+                      <a:prstDash val="solid"/>
+                      <a:round/>
+                      <a:headEnd type="none" w="med" len="med"/>
+                      <a:tailEnd type="none" w="med" len="med"/>
+                    </a:lnL>
+                    <a:lnR w="12700" cap="flat" cmpd="sng" algn="ctr">
+                      <a:solidFill>
+                        <a:srgbClr val="40454F"/>
+                      </a:solidFill>
+                      <a:prstDash val="solid"/>
+                      <a:round/>
+                      <a:headEnd type="none" w="med" len="med"/>
+                      <a:tailEnd type="none" w="med" len="med"/>
+                    </a:lnR>
+                    <a:lnT w="12700" cap="flat" cmpd="sng" algn="ctr">
+                      <a:solidFill>
+                        <a:srgbClr val="40454F"/>
+                      </a:solidFill>
+                      <a:prstDash val="solid"/>
+                      <a:round/>
+                      <a:headEnd type="none" w="med" len="med"/>
+                      <a:tailEnd type="none" w="med" len="med"/>
+                    </a:lnT>
+                    <a:lnB w="12700" cap="flat" cmpd="sng" algn="ctr">
+                      <a:solidFill>
+                        <a:srgbClr val="40454F"/>
+                      </a:solidFill>
+                      <a:prstDash val="solid"/>
+                      <a:round/>
+                      <a:headEnd type="none" w="med" len="med"/>
+                      <a:tailEnd type="none" w="med" len="med"/>
+                    </a:lnB>
+                  </a:tcPr>
+                </a:tc>
+                <a:tc>
+                  <a:txBody>
+                    <a:bodyPr/>
+                    <a:lstStyle/>
+                    <a:p>
+                      <a:pPr indent="0" marL="0">
+                        <a:lnSpc>
+                          <a:spcPts val="1960"/>
+                        </a:lnSpc>
+                        <a:buNone/>
+                      </a:pPr>
+                      <a:r>
+                        <a:rPr lang="en-US" sz="1400" dirty="0">
+                          <a:solidFill>
+                            <a:srgbClr val="E8ECF4"/>
+                          </a:solidFill>
+                          <a:latin typeface="IBM Plex Sans" pitchFamily="34" charset="0"/>
+                          <a:ea typeface="IBM Plex Sans" pitchFamily="34" charset="-122"/>
+                          <a:cs typeface="IBM Plex Sans" pitchFamily="34" charset="-120"/>
+                        </a:rPr>
                         <a:t>Sign in as viewer</a:t>
                       </a:r>
                       <a:endParaRPr lang="en-US" sz="1400" dirty="0">
@@ -7661,7 +8881,7 @@
                 <a:ea typeface="IBM Plex Sans" pitchFamily="34" charset="-122"/>
                 <a:cs typeface="IBM Plex Sans" pitchFamily="34" charset="-120"/>
               </a:rPr>
-              <a:t>CloudLens · Capstone viva · 14</a:t>
+              <a:t>CloudLens · Capstone viva · 16</a:t>
             </a:r>
             <a:endParaRPr lang="en-US" sz="1200" dirty="0">
               <a:latin typeface="IBM Plex Sans" charset="0"/>
@@ -7679,7 +8899,7 @@
 </p:sld>
 </file>
 
-<file path=ppt/slides/slide15.xml><?xml version="1.0" encoding="utf-8"?>
+<file path=ppt/slides/slide17.xml><?xml version="1.0" encoding="utf-8"?>
 <p:sld xmlns:a="http://schemas.openxmlformats.org/drawingml/2006/main" xmlns:r="http://schemas.openxmlformats.org/officeDocument/2006/relationships" xmlns:p="http://schemas.openxmlformats.org/presentationml/2006/main">
   <p:cSld name="Slide 15">
     <p:bg>
@@ -7827,6 +9047,10 @@
             <a:prstDash val="solid"/>
           </a:ln>
         </p:spPr>
+        <p:txBody>
+          <a:bodyPr/>
+          <a:p/>
+        </p:txBody>
       </p:sp>
       <p:sp>
         <p:nvSpPr>
@@ -8026,6 +9250,10 @@
             <a:prstDash val="solid"/>
           </a:ln>
         </p:spPr>
+        <p:txBody>
+          <a:bodyPr/>
+          <a:p/>
+        </p:txBody>
       </p:sp>
       <p:sp>
         <p:nvSpPr>
@@ -8237,7 +9465,7 @@
                 <a:ea typeface="IBM Plex Sans" pitchFamily="34" charset="-122"/>
                 <a:cs typeface="IBM Plex Sans" pitchFamily="34" charset="-120"/>
               </a:rPr>
-              <a:t>CloudLens · Capstone viva · 15</a:t>
+              <a:t>CloudLens · Capstone viva · 17</a:t>
             </a:r>
             <a:endParaRPr lang="en-US" sz="1200" dirty="0">
               <a:latin typeface="IBM Plex Sans" charset="0"/>
@@ -8255,7 +9483,7 @@
 </p:sld>
 </file>
 
-<file path=ppt/slides/slide16.xml><?xml version="1.0" encoding="utf-8"?>
+<file path=ppt/slides/slide18.xml><?xml version="1.0" encoding="utf-8"?>
 <p:sld xmlns:a="http://schemas.openxmlformats.org/drawingml/2006/main" xmlns:r="http://schemas.openxmlformats.org/officeDocument/2006/relationships" xmlns:p="http://schemas.openxmlformats.org/presentationml/2006/main">
   <p:cSld name="Slide 16">
     <p:bg>
@@ -8685,6 +9913,10 @@
             <a:prstDash val="solid"/>
           </a:ln>
         </p:spPr>
+        <p:txBody>
+          <a:bodyPr/>
+          <a:p/>
+        </p:txBody>
       </p:sp>
       <p:sp>
         <p:nvSpPr>
@@ -8808,6 +10040,10 @@
             <a:prstDash val="solid"/>
           </a:ln>
         </p:spPr>
+        <p:txBody>
+          <a:bodyPr/>
+          <a:p/>
+        </p:txBody>
       </p:sp>
       <p:sp>
         <p:nvSpPr>
@@ -8931,6 +10167,10 @@
             <a:prstDash val="solid"/>
           </a:ln>
         </p:spPr>
+        <p:txBody>
+          <a:bodyPr/>
+          <a:p/>
+        </p:txBody>
       </p:sp>
       <p:sp>
         <p:nvSpPr>
@@ -9280,6 +10520,10 @@
             <a:prstDash val="solid"/>
           </a:ln>
         </p:spPr>
+        <p:txBody>
+          <a:bodyPr/>
+          <a:p/>
+        </p:txBody>
       </p:sp>
       <p:sp>
         <p:nvSpPr>
@@ -9451,6 +10695,10 @@
             <a:prstDash val="solid"/>
           </a:ln>
         </p:spPr>
+        <p:txBody>
+          <a:bodyPr/>
+          <a:p/>
+        </p:txBody>
       </p:sp>
       <p:sp>
         <p:nvSpPr>
@@ -9622,6 +10870,10 @@
             <a:prstDash val="solid"/>
           </a:ln>
         </p:spPr>
+        <p:txBody>
+          <a:bodyPr/>
+          <a:p/>
+        </p:txBody>
       </p:sp>
       <p:sp>
         <p:nvSpPr>
@@ -9793,6 +11045,10 @@
             <a:prstDash val="solid"/>
           </a:ln>
         </p:spPr>
+        <p:txBody>
+          <a:bodyPr/>
+          <a:p/>
+        </p:txBody>
       </p:sp>
       <p:sp>
         <p:nvSpPr>
@@ -12928,7 +14184,7 @@
                           <a:ea typeface="IBM Plex Sans" pitchFamily="34" charset="-122"/>
                           <a:cs typeface="IBM Plex Sans" pitchFamily="34" charset="-120"/>
                         </a:rPr>
-                        <a:t>environment$prod</a:t>
+                        <a:t>chosen per connection</a:t>
                       </a:r>
                       <a:endParaRPr lang="en-US" sz="1300" dirty="0">
                         <a:latin typeface="IBM Plex Sans" charset="0"/>
@@ -12996,7 +14252,7 @@
                           <a:ea typeface="IBM Plex Sans" pitchFamily="34" charset="-122"/>
                           <a:cs typeface="IBM Plex Sans" pitchFamily="34" charset="-120"/>
                         </a:rPr>
-                        <a:t>tag value</a:t>
+                        <a:t>chosen per connection</a:t>
                       </a:r>
                       <a:endParaRPr lang="en-US" sz="1300" dirty="0">
                         <a:latin typeface="IBM Plex Sans" charset="0"/>
@@ -13064,7 +14320,7 @@
                           <a:ea typeface="IBM Plex Sans" pitchFamily="34" charset="-122"/>
                           <a:cs typeface="IBM Plex Sans" pitchFamily="34" charset="-120"/>
                         </a:rPr>
-                        <a:t>label value</a:t>
+                        <a:t>chosen per connection</a:t>
                       </a:r>
                       <a:endParaRPr lang="en-US" sz="1300" dirty="0">
                         <a:latin typeface="IBM Plex Sans" charset="0"/>
@@ -13438,18 +14694,7 @@
                 <a:ea typeface="IBM Plex Sans" pitchFamily="34" charset="-122"/>
                 <a:cs typeface="IBM Plex Sans" pitchFamily="34" charset="-120"/>
               </a:rPr>
-              <a:t>Normaliser</a:t>
-            </a:r>
-            <a:r>
-              <a:rPr lang="en-US" sz="1400" dirty="0">
-                <a:solidFill>
-                  <a:srgbClr val="0F172A"/>
-                </a:solidFill>
-                <a:latin typeface="IBM Plex Sans" pitchFamily="34" charset="0"/>
-                <a:ea typeface="IBM Plex Sans" pitchFamily="34" charset="-122"/>
-                <a:cs typeface="IBM Plex Sans" pitchFamily="34" charset="-120"/>
-              </a:rPr>
-              <a:t> maps services to 6 types, tags to 4 environments</a:t>
+              <a:t>Normaliser maps services to 6 types; each connection sets its environment</a:t>
             </a:r>
             <a:endParaRPr lang="en-US" sz="1400" dirty="0">
               <a:latin typeface="IBM Plex Sans" charset="0"/>
@@ -13931,7 +15176,7 @@
           <p:nvPr/>
         </p:nvPicPr>
         <p:blipFill>
-          <a:blip r:embed="rId1"/>
+          <a:blip r:embed="rId4"/>
           <a:stretch>
             <a:fillRect/>
           </a:stretch>
@@ -13970,6 +15215,10 @@
             <a:prstDash val="solid"/>
           </a:ln>
         </p:spPr>
+        <p:txBody>
+          <a:bodyPr/>
+          <a:p/>
+        </p:txBody>
       </p:sp>
       <p:sp>
         <p:nvSpPr>
@@ -14288,7 +15537,7 @@
                 <a:ea typeface="IBM Plex Sans" pitchFamily="34" charset="-122"/>
                 <a:cs typeface="IBM Plex Sans" pitchFamily="34" charset="-120"/>
               </a:rPr>
-              <a:t>Reports for any range, e.g. last 6 months, CSV</a:t>
+              <a:t>Reports use the same filters, with CSV and PDF</a:t>
             </a:r>
             <a:endParaRPr lang="en-US" sz="1500" dirty="0">
               <a:latin typeface="IBM Plex Sans" charset="0"/>
@@ -14307,7 +15556,7 @@
           <p:nvPr/>
         </p:nvPicPr>
         <p:blipFill>
-          <a:blip r:embed="rId1"/>
+          <a:blip r:embed="rId4"/>
           <a:stretch>
             <a:fillRect/>
           </a:stretch>
@@ -14346,6 +15595,10 @@
             <a:prstDash val="solid"/>
           </a:ln>
         </p:spPr>
+        <p:txBody>
+          <a:bodyPr/>
+          <a:p/>
+        </p:txBody>
       </p:sp>
       <p:sp>
         <p:nvSpPr>
@@ -14405,11 +15658,11 @@
 
 <file path=ppt/slides/slide9.xml><?xml version="1.0" encoding="utf-8"?>
 <p:sld xmlns:a="http://schemas.openxmlformats.org/drawingml/2006/main" xmlns:r="http://schemas.openxmlformats.org/officeDocument/2006/relationships" xmlns:p="http://schemas.openxmlformats.org/presentationml/2006/main">
-  <p:cSld name="Slide 9">
+  <p:cSld name="Slide 7">
     <p:bg>
       <p:bgPr>
         <a:solidFill>
-          <a:srgbClr val="FBFBF8"/>
+          <a:srgbClr val="0B1220"/>
         </a:solidFill>
       </p:bgPr>
     </p:bg>
@@ -14435,7 +15688,282 @@
         </p:nvSpPr>
         <p:spPr>
           <a:xfrm>
-            <a:off x="812800" y="812800"/>
+            <a:off x="812800" y="1271935"/>
+            <a:ext cx="3401060" cy="238720"/>
+          </a:xfrm>
+          <a:prstGeom prst="rect">
+            <a:avLst/>
+          </a:prstGeom>
+          <a:noFill/>
+          <a:ln/>
+        </p:spPr>
+        <p:txBody>
+          <a:bodyPr wrap="square" lIns="0" tIns="0" rIns="0" bIns="0" rtlCol="0" anchor="t">
+            <a:normAutofit/>
+          </a:bodyPr>
+          <a:lstStyle/>
+          <a:p>
+            <a:pPr algn="l" indent="0" marL="0">
+              <a:lnSpc>
+                <a:spcPts val="1680"/>
+              </a:lnSpc>
+              <a:buNone/>
+            </a:pPr>
+            <a:r>
+              <a:rPr lang="en-US" sz="1200" spc="150" kern="0" dirty="0">
+                <a:solidFill>
+                  <a:srgbClr val="5B9BFF"/>
+                </a:solidFill>
+                <a:latin typeface="JetBrains Mono" pitchFamily="49" charset="0"/>
+                <a:ea typeface="JetBrains Mono" pitchFamily="49" charset="-122"/>
+                <a:cs typeface="JetBrains Mono" pitchFamily="49" charset="-120"/>
+              </a:rPr>
+              <a:t>DATA SOURCE</a:t>
+            </a:r>
+            <a:endParaRPr lang="en-US" sz="1200" dirty="0">
+              <a:latin typeface="JetBrains Mono" charset="0"/>
+              <a:ea typeface="JetBrains Mono" charset="0"/>
+              <a:cs typeface="JetBrains Mono" charset="0"/>
+            </a:endParaRPr>
+          </a:p>
+        </p:txBody>
+      </p:sp>
+      <p:sp>
+        <p:nvSpPr>
+          <p:cNvPr id="3" name="Text 1"/>
+          <p:cNvSpPr/>
+          <p:nvPr>
+            <p:ph type="title"/>
+          </p:nvPr>
+        </p:nvSpPr>
+        <p:spPr>
+          <a:xfrm>
+            <a:off x="812800" y="1663055"/>
+            <a:ext cx="3401060" cy="919460"/>
+          </a:xfrm>
+          <a:prstGeom prst="rect">
+            <a:avLst/>
+          </a:prstGeom>
+          <a:noFill/>
+          <a:ln/>
+        </p:spPr>
+        <p:txBody>
+          <a:bodyPr wrap="square" lIns="0" tIns="0" rIns="0" bIns="0" rtlCol="0" anchor="t">
+            <a:normAutofit/>
+          </a:bodyPr>
+          <a:lstStyle/>
+          <a:p>
+            <a:pPr algn="l" indent="0" marL="0">
+              <a:lnSpc>
+                <a:spcPts val="3520"/>
+              </a:lnSpc>
+              <a:buNone/>
+            </a:pPr>
+            <a:r>
+              <a:rPr lang="en-US" sz="3200" b="1" i="0" dirty="0">
+                <a:solidFill>
+                  <a:srgbClr val="E8ECF4"/>
+                </a:solidFill>
+                <a:latin typeface="IBM Plex Sans" pitchFamily="34" charset="0"/>
+                <a:ea typeface="IBM Plex Sans" pitchFamily="34" charset="-122"/>
+                <a:cs typeface="IBM Plex Sans" pitchFamily="34" charset="-120"/>
+              </a:rPr>
+              <a:t>Mock or Live, per cloud</a:t>
+            </a:r>
+            <a:endParaRPr lang="en-US" sz="3200" dirty="0">
+              <a:latin typeface="IBM Plex Sans" charset="0"/>
+              <a:ea typeface="IBM Plex Sans" charset="0"/>
+              <a:cs typeface="IBM Plex Sans" charset="0"/>
+            </a:endParaRPr>
+          </a:p>
+        </p:txBody>
+      </p:sp>
+      <p:sp>
+        <p:nvSpPr>
+          <p:cNvPr id="4" name="Text 2"/>
+          <p:cNvSpPr/>
+          <p:nvPr/>
+        </p:nvSpPr>
+        <p:spPr>
+          <a:xfrm>
+            <a:off x="883920" y="2734915"/>
+            <a:ext cx="3322320" cy="2597150"/>
+          </a:xfrm>
+          <a:prstGeom prst="rect">
+            <a:avLst/>
+          </a:prstGeom>
+          <a:noFill/>
+          <a:ln/>
+        </p:spPr>
+        <p:txBody>
+          <a:bodyPr wrap="square" lIns="0" tIns="0" rIns="0" bIns="0" rtlCol="0" anchor="t">
+            <a:normAutofit/>
+          </a:bodyPr>
+          <a:lstStyle/>
+          <a:p>
+            <a:pPr algn="l" marL="182880" indent="-182880">
+              <a:lnSpc>
+                <a:spcPts val="2250"/>
+              </a:lnSpc>
+              <a:buSzPct val="100000"/>
+              <a:buChar char="•"/>
+            </a:pPr>
+            <a:r>
+              <a:rPr lang="en-US" sz="1500" dirty="0">
+                <a:solidFill>
+                  <a:srgbClr val="C9D3E3"/>
+                </a:solidFill>
+                <a:latin typeface="IBM Plex Sans" pitchFamily="34" charset="0"/>
+                <a:ea typeface="IBM Plex Sans" pitchFamily="34" charset="-122"/>
+                <a:cs typeface="IBM Plex Sans" pitchFamily="34" charset="-120"/>
+              </a:rPr>
+              <a:t>Every cloud starts on Mock, no credentials needed</a:t>
+            </a:r>
+            <a:endParaRPr lang="en-US" sz="1500" dirty="0">
+              <a:latin typeface="IBM Plex Sans" charset="0"/>
+              <a:ea typeface="IBM Plex Sans" charset="0"/>
+              <a:cs typeface="IBM Plex Sans" charset="0"/>
+            </a:endParaRPr>
+          </a:p>
+          <a:p>
+            <a:pPr algn="l" marL="182880" indent="-182880">
+              <a:lnSpc>
+                <a:spcPts val="2250"/>
+              </a:lnSpc>
+              <a:buSzPct val="100000"/>
+              <a:buChar char="•"/>
+            </a:pPr>
+            <a:r>
+              <a:rPr lang="en-US" sz="1500" dirty="0">
+                <a:solidFill>
+                  <a:srgbClr val="C9D3E3"/>
+                </a:solidFill>
+                <a:latin typeface="IBM Plex Sans" pitchFamily="34" charset="0"/>
+                <a:ea typeface="IBM Plex Sans" pitchFamily="34" charset="-122"/>
+                <a:cs typeface="IBM Plex Sans" pitchFamily="34" charset="-120"/>
+              </a:rPr>
+              <a:t>Live: one real account per environment, linked to the Environment filter</a:t>
+            </a:r>
+            <a:endParaRPr lang="en-US" sz="1500" dirty="0">
+              <a:latin typeface="IBM Plex Sans" charset="0"/>
+              <a:ea typeface="IBM Plex Sans" charset="0"/>
+              <a:cs typeface="IBM Plex Sans" charset="0"/>
+            </a:endParaRPr>
+          </a:p>
+          <a:p>
+            <a:pPr algn="l" marL="182880" indent="-182880">
+              <a:lnSpc>
+                <a:spcPts val="2250"/>
+              </a:lnSpc>
+              <a:buSzPct val="100000"/>
+              <a:buChar char="•"/>
+            </a:pPr>
+            <a:r>
+              <a:rPr lang="en-US" sz="1500" dirty="0">
+                <a:solidFill>
+                  <a:srgbClr val="C9D3E3"/>
+                </a:solidFill>
+                <a:latin typeface="IBM Plex Sans" pitchFamily="34" charset="0"/>
+                <a:ea typeface="IBM Plex Sans" pitchFamily="34" charset="-122"/>
+                <a:cs typeface="IBM Plex Sans" pitchFamily="34" charset="-120"/>
+              </a:rPr>
+              <a:t>Environments not configured show no data</a:t>
+            </a:r>
+            <a:endParaRPr lang="en-US" sz="1500" dirty="0">
+              <a:latin typeface="IBM Plex Sans" charset="0"/>
+              <a:ea typeface="IBM Plex Sans" charset="0"/>
+              <a:cs typeface="IBM Plex Sans" charset="0"/>
+            </a:endParaRPr>
+          </a:p>
+          <a:p>
+            <a:pPr algn="l" marL="182880" indent="-182880">
+              <a:lnSpc>
+                <a:spcPts val="2250"/>
+              </a:lnSpc>
+              <a:buSzPct val="100000"/>
+              <a:buChar char="•"/>
+            </a:pPr>
+            <a:r>
+              <a:rPr lang="en-US" sz="1500" dirty="0">
+                <a:solidFill>
+                  <a:srgbClr val="C9D3E3"/>
+                </a:solidFill>
+                <a:latin typeface="IBM Plex Sans" pitchFamily="34" charset="0"/>
+                <a:ea typeface="IBM Plex Sans" pitchFamily="34" charset="-122"/>
+                <a:cs typeface="IBM Plex Sans" pitchFamily="34" charset="-120"/>
+              </a:rPr>
+              <a:t>Both data sets are kept, so switching back loses nothing</a:t>
+            </a:r>
+            <a:endParaRPr lang="en-US" sz="1500" dirty="0">
+              <a:latin typeface="IBM Plex Sans" charset="0"/>
+              <a:ea typeface="IBM Plex Sans" charset="0"/>
+              <a:cs typeface="IBM Plex Sans" charset="0"/>
+            </a:endParaRPr>
+          </a:p>
+        </p:txBody>
+      </p:sp>
+      <p:pic>
+        <p:nvPicPr>
+          <p:cNvPr id="5" name="Image 0" descr="Cloud Accounts screen: AWS set to Live with Production and Staging connections validated, Azure and GCP set to Mock, each with a mode dropdown and Configuration button">    </p:cNvPr>
+          <p:cNvPicPr>
+            <a:picLocks noChangeAspect="1"/>
+          </p:cNvPicPr>
+          <p:nvPr/>
+        </p:nvPicPr>
+        <p:blipFill>
+          <a:blip r:embed="rId3"/>
+          <a:stretch>
+            <a:fillRect/>
+          </a:stretch>
+        </p:blipFill>
+        <p:spPr>
+          <a:xfrm>
+            <a:off x="4620239" y="1691640"/>
+            <a:ext cx="6606073" cy="2697479"/>
+          </a:xfrm>
+          <a:prstGeom prst="rect">
+            <a:avLst/>
+          </a:prstGeom>
+        </p:spPr>
+      </p:pic>
+      <p:sp>
+        <p:nvSpPr>
+          <p:cNvPr id="6" name="Shape 3"/>
+          <p:cNvSpPr/>
+          <p:nvPr/>
+        </p:nvSpPr>
+        <p:spPr>
+          <a:xfrm>
+            <a:off x="4471416" y="1600200"/>
+            <a:ext cx="6903720" cy="2880360"/>
+          </a:xfrm>
+          <a:prstGeom prst="roundRect">
+            <a:avLst>
+              <a:gd name="adj" fmla="val 1847"/>
+            </a:avLst>
+          </a:prstGeom>
+          <a:noFill/>
+          <a:ln w="6350">
+            <a:solidFill>
+              <a:srgbClr val="243047"/>
+            </a:solidFill>
+            <a:prstDash val="solid"/>
+          </a:ln>
+        </p:spPr>
+        <p:txBody>
+          <a:bodyPr/>
+          <a:p/>
+        </p:txBody>
+      </p:sp>
+      <p:sp>
+        <p:nvSpPr>
+          <p:cNvPr id="7" name="Text 4"/>
+          <p:cNvSpPr/>
+          <p:nvPr/>
+        </p:nvSpPr>
+        <p:spPr>
+          <a:xfrm>
+            <a:off x="812800" y="6289080"/>
             <a:ext cx="10883392" cy="238720"/>
           </a:xfrm>
           <a:prstGeom prst="rect">
@@ -14457,36 +15985,34 @@
               <a:buNone/>
             </a:pPr>
             <a:r>
-              <a:rPr lang="en-US" sz="1200" spc="150" kern="0" dirty="0">
+              <a:rPr lang="en-US" sz="1200" dirty="0">
                 <a:solidFill>
-                  <a:srgbClr val="1D5FD6"/>
+                  <a:srgbClr val="A9B4C8"/>
                 </a:solidFill>
-                <a:latin typeface="JetBrains Mono" pitchFamily="49" charset="0"/>
-                <a:ea typeface="JetBrains Mono" pitchFamily="49" charset="-122"/>
-                <a:cs typeface="JetBrains Mono" pitchFamily="49" charset="-120"/>
+                <a:latin typeface="IBM Plex Sans" pitchFamily="34" charset="0"/>
+                <a:ea typeface="IBM Plex Sans" pitchFamily="34" charset="-122"/>
+                <a:cs typeface="IBM Plex Sans" pitchFamily="34" charset="-120"/>
               </a:rPr>
-              <a:t>ALERTING PIPELINE</a:t>
+              <a:t>CloudLens · Capstone viva · 9</a:t>
             </a:r>
             <a:endParaRPr lang="en-US" sz="1200" dirty="0">
-              <a:latin typeface="JetBrains Mono" charset="0"/>
-              <a:ea typeface="JetBrains Mono" charset="0"/>
-              <a:cs typeface="JetBrains Mono" charset="0"/>
+              <a:latin typeface="IBM Plex Sans" charset="0"/>
+              <a:ea typeface="IBM Plex Sans" charset="0"/>
+              <a:cs typeface="IBM Plex Sans" charset="0"/>
             </a:endParaRPr>
           </a:p>
         </p:txBody>
       </p:sp>
       <p:sp>
         <p:nvSpPr>
-          <p:cNvPr id="3" name="Text 1"/>
+          <p:cNvPr id="7" name="Caption"/>
           <p:cNvSpPr/>
-          <p:nvPr>
-            <p:ph type="title"/>
-          </p:nvPr>
+          <p:nvPr/>
         </p:nvSpPr>
         <p:spPr>
           <a:xfrm>
-            <a:off x="812800" y="1127720"/>
-            <a:ext cx="10883392" cy="528290"/>
+            <a:off x="4471416" y="4553712"/>
+            <a:ext cx="6903720" cy="238720"/>
           </a:xfrm>
           <a:prstGeom prst="rect">
             <a:avLst/>
@@ -14502,306 +16028,20 @@
           <a:p>
             <a:pPr algn="l" indent="0" marL="0">
               <a:lnSpc>
-                <a:spcPts val="3960"/>
+                <a:spcPts val="1680"/>
               </a:lnSpc>
               <a:buNone/>
             </a:pPr>
             <a:r>
-              <a:rPr lang="en-US" sz="3600" b="1" i="0" dirty="0">
+              <a:rPr lang="en-US" sz="1200" dirty="0">
                 <a:solidFill>
-                  <a:srgbClr val="0F172A"/>
+                  <a:srgbClr val="A9B4C8"/>
                 </a:solidFill>
                 <a:latin typeface="IBM Plex Sans" pitchFamily="34" charset="0"/>
                 <a:ea typeface="IBM Plex Sans" pitchFamily="34" charset="-122"/>
                 <a:cs typeface="IBM Plex Sans" pitchFamily="34" charset="-120"/>
               </a:rPr>
-              <a:t>Rules in the UI, delivery by Prometheus</a:t>
-            </a:r>
-            <a:endParaRPr lang="en-US" sz="3600" dirty="0">
-              <a:latin typeface="IBM Plex Sans" charset="0"/>
-              <a:ea typeface="IBM Plex Sans" charset="0"/>
-              <a:cs typeface="IBM Plex Sans" charset="0"/>
-            </a:endParaRPr>
-          </a:p>
-        </p:txBody>
-      </p:sp>
-      <p:pic>
-        <p:nvPicPr>
-          <p:cNvPr id="4" name="Image 0" descr="Alert flow: rule defined in UI, alert engine sets a gauge, Prometheus fires, Alertmanager groups and routes, webhook stores the event, Slack and Microsoft Teams receive messages">    </p:cNvPr>
-          <p:cNvPicPr>
-            <a:picLocks noChangeAspect="1"/>
-          </p:cNvPicPr>
-          <p:nvPr/>
-        </p:nvPicPr>
-        <p:blipFill>
-          <a:blip r:embed="rId1"/>
-          <a:srcRect l="-6523" r="-6523" t="0" b="0"/>
-          <a:stretch/>
-        </p:blipFill>
-        <p:spPr>
-          <a:xfrm>
-            <a:off x="812800" y="1884611"/>
-            <a:ext cx="10566400" cy="2349500"/>
-          </a:xfrm>
-          <a:prstGeom prst="rect">
-            <a:avLst/>
-          </a:prstGeom>
-        </p:spPr>
-      </p:pic>
-      <p:sp>
-        <p:nvSpPr>
-          <p:cNvPr id="5" name="Text 2"/>
-          <p:cNvSpPr/>
-          <p:nvPr/>
-        </p:nvSpPr>
-        <p:spPr>
-          <a:xfrm>
-            <a:off x="815975" y="4491286"/>
-            <a:ext cx="3414167" cy="808930"/>
-          </a:xfrm>
-          <a:prstGeom prst="roundRect">
-            <a:avLst>
-              <a:gd name="adj" fmla="val 12167"/>
-            </a:avLst>
-          </a:prstGeom>
-          <a:solidFill>
-            <a:srgbClr val="FFFFFF"/>
-          </a:solidFill>
-          <a:ln w="6350">
-            <a:solidFill>
-              <a:srgbClr val="DCE2EB"/>
-            </a:solidFill>
-            <a:prstDash val="solid"/>
-          </a:ln>
-        </p:spPr>
-        <p:txBody>
-          <a:bodyPr wrap="square" lIns="152147" tIns="126747" rIns="60581" bIns="101347" rtlCol="0" anchor="t">
-            <a:normAutofit/>
-          </a:bodyPr>
-          <a:lstStyle/>
-          <a:p>
-            <a:pPr algn="l" indent="0" marL="0">
-              <a:lnSpc>
-                <a:spcPts val="1960"/>
-              </a:lnSpc>
-              <a:buNone/>
-            </a:pPr>
-            <a:r>
-              <a:rPr lang="en-US" sz="1400" dirty="0">
-                <a:solidFill>
-                  <a:srgbClr val="0F172A"/>
-                </a:solidFill>
-                <a:latin typeface="IBM Plex Sans" pitchFamily="34" charset="0"/>
-                <a:ea typeface="IBM Plex Sans" pitchFamily="34" charset="-122"/>
-                <a:cs typeface="IBM Plex Sans" pitchFamily="34" charset="-120"/>
-              </a:rPr>
-              <a:t>One gauge per rule: </a:t>
-            </a:r>
-            <a:r>
-              <a:rPr lang="en-US" sz="1400" b="1" dirty="0">
-                <a:solidFill>
-                  <a:srgbClr val="0F172A"/>
-                </a:solidFill>
-                <a:latin typeface="IBM Plex Sans" pitchFamily="34" charset="0"/>
-                <a:ea typeface="IBM Plex Sans" pitchFamily="34" charset="-122"/>
-                <a:cs typeface="IBM Plex Sans" pitchFamily="34" charset="-120"/>
-              </a:rPr>
-              <a:t>cloudlens_alert_rule_breached</a:t>
-            </a:r>
-            <a:endParaRPr lang="en-US" sz="1400" dirty="0">
-              <a:latin typeface="IBM Plex Sans" charset="0"/>
-              <a:ea typeface="IBM Plex Sans" charset="0"/>
-              <a:cs typeface="IBM Plex Sans" charset="0"/>
-            </a:endParaRPr>
-          </a:p>
-        </p:txBody>
-      </p:sp>
-      <p:sp>
-        <p:nvSpPr>
-          <p:cNvPr id="6" name="Text 3"/>
-          <p:cNvSpPr/>
-          <p:nvPr/>
-        </p:nvSpPr>
-        <p:spPr>
-          <a:xfrm>
-            <a:off x="4388892" y="4491286"/>
-            <a:ext cx="3414216" cy="808930"/>
-          </a:xfrm>
-          <a:prstGeom prst="roundRect">
-            <a:avLst>
-              <a:gd name="adj" fmla="val 12167"/>
-            </a:avLst>
-          </a:prstGeom>
-          <a:solidFill>
-            <a:srgbClr val="FFFFFF"/>
-          </a:solidFill>
-          <a:ln w="6350">
-            <a:solidFill>
-              <a:srgbClr val="DCE2EB"/>
-            </a:solidFill>
-            <a:prstDash val="solid"/>
-          </a:ln>
-        </p:spPr>
-        <p:txBody>
-          <a:bodyPr wrap="square" lIns="152147" tIns="126747" rIns="60579" bIns="101347" rtlCol="0" anchor="t">
-            <a:normAutofit/>
-          </a:bodyPr>
-          <a:lstStyle/>
-          <a:p>
-            <a:pPr algn="l" indent="0" marL="0">
-              <a:lnSpc>
-                <a:spcPts val="1960"/>
-              </a:lnSpc>
-              <a:buNone/>
-            </a:pPr>
-            <a:r>
-              <a:rPr lang="en-US" sz="1400" dirty="0">
-                <a:solidFill>
-                  <a:srgbClr val="0F172A"/>
-                </a:solidFill>
-                <a:latin typeface="IBM Plex Sans" pitchFamily="34" charset="0"/>
-                <a:ea typeface="IBM Plex Sans" pitchFamily="34" charset="-122"/>
-                <a:cs typeface="IBM Plex Sans" pitchFamily="34" charset="-120"/>
-              </a:rPr>
-              <a:t>Grouping, dedupe, 4 h repeat, </a:t>
-            </a:r>
-            <a:r>
-              <a:rPr lang="en-US" sz="1400" b="1" dirty="0">
-                <a:solidFill>
-                  <a:srgbClr val="0F172A"/>
-                </a:solidFill>
-                <a:latin typeface="IBM Plex Sans" pitchFamily="34" charset="0"/>
-                <a:ea typeface="IBM Plex Sans" pitchFamily="34" charset="-122"/>
-                <a:cs typeface="IBM Plex Sans" pitchFamily="34" charset="-120"/>
-              </a:rPr>
-              <a:t>resolved</a:t>
-            </a:r>
-            <a:r>
-              <a:rPr lang="en-US" sz="1400" dirty="0">
-                <a:solidFill>
-                  <a:srgbClr val="0F172A"/>
-                </a:solidFill>
-                <a:latin typeface="IBM Plex Sans" pitchFamily="34" charset="0"/>
-                <a:ea typeface="IBM Plex Sans" pitchFamily="34" charset="-122"/>
-                <a:cs typeface="IBM Plex Sans" pitchFamily="34" charset="-120"/>
-              </a:rPr>
-              <a:t> messages</a:t>
-            </a:r>
-            <a:endParaRPr lang="en-US" sz="1400" dirty="0">
-              <a:latin typeface="IBM Plex Sans" charset="0"/>
-              <a:ea typeface="IBM Plex Sans" charset="0"/>
-              <a:cs typeface="IBM Plex Sans" charset="0"/>
-            </a:endParaRPr>
-          </a:p>
-        </p:txBody>
-      </p:sp>
-      <p:sp>
-        <p:nvSpPr>
-          <p:cNvPr id="7" name="Text 4"/>
-          <p:cNvSpPr/>
-          <p:nvPr/>
-        </p:nvSpPr>
-        <p:spPr>
-          <a:xfrm>
-            <a:off x="7961858" y="4491286"/>
-            <a:ext cx="3414167" cy="808930"/>
-          </a:xfrm>
-          <a:prstGeom prst="roundRect">
-            <a:avLst>
-              <a:gd name="adj" fmla="val 12167"/>
-            </a:avLst>
-          </a:prstGeom>
-          <a:solidFill>
-            <a:srgbClr val="FFFFFF"/>
-          </a:solidFill>
-          <a:ln w="6350">
-            <a:solidFill>
-              <a:srgbClr val="DCE2EB"/>
-            </a:solidFill>
-            <a:prstDash val="solid"/>
-          </a:ln>
-        </p:spPr>
-        <p:txBody>
-          <a:bodyPr wrap="none" lIns="0" tIns="126747" rIns="0" bIns="101347" rtlCol="0" anchor="t">
-            <a:normAutofit/>
-          </a:bodyPr>
-          <a:lstStyle/>
-          <a:p>
-            <a:pPr algn="ctr" indent="0" marL="0">
-              <a:lnSpc>
-                <a:spcPts val="1960"/>
-              </a:lnSpc>
-              <a:buNone/>
-            </a:pPr>
-            <a:r>
-              <a:rPr lang="en-US" sz="1400" dirty="0">
-                <a:solidFill>
-                  <a:srgbClr val="0F172A"/>
-                </a:solidFill>
-                <a:latin typeface="IBM Plex Sans" pitchFamily="34" charset="0"/>
-                <a:ea typeface="IBM Plex Sans" pitchFamily="34" charset="-122"/>
-                <a:cs typeface="IBM Plex Sans" pitchFamily="34" charset="-120"/>
-              </a:rPr>
-              <a:t>Webhook protected by a </a:t>
-            </a:r>
-            <a:r>
-              <a:rPr lang="en-US" sz="1400" b="1" dirty="0">
-                <a:solidFill>
-                  <a:srgbClr val="0F172A"/>
-                </a:solidFill>
-                <a:latin typeface="IBM Plex Sans" pitchFamily="34" charset="0"/>
-                <a:ea typeface="IBM Plex Sans" pitchFamily="34" charset="-122"/>
-                <a:cs typeface="IBM Plex Sans" pitchFamily="34" charset="-120"/>
-              </a:rPr>
-              <a:t>bearer token</a:t>
-            </a:r>
-            <a:endParaRPr lang="en-US" sz="1400" dirty="0">
-              <a:latin typeface="IBM Plex Sans" charset="0"/>
-              <a:ea typeface="IBM Plex Sans" charset="0"/>
-              <a:cs typeface="IBM Plex Sans" charset="0"/>
-            </a:endParaRPr>
-          </a:p>
-        </p:txBody>
-      </p:sp>
-      <p:sp>
-        <p:nvSpPr>
-          <p:cNvPr id="8" name="Text 5"/>
-          <p:cNvSpPr/>
-          <p:nvPr/>
-        </p:nvSpPr>
-        <p:spPr>
-          <a:xfrm>
-            <a:off x="812800" y="6238280"/>
-            <a:ext cx="10883392" cy="238720"/>
-          </a:xfrm>
-          <a:prstGeom prst="rect">
-            <a:avLst/>
-          </a:prstGeom>
-          <a:noFill/>
-          <a:ln/>
-        </p:spPr>
-        <p:txBody>
-          <a:bodyPr wrap="square" lIns="0" tIns="0" rIns="0" bIns="0" rtlCol="0" anchor="t">
-            <a:normAutofit/>
-          </a:bodyPr>
-          <a:lstStyle/>
-          <a:p>
-            <a:pPr algn="l" indent="0" marL="0">
-              <a:lnSpc>
-                <a:spcPts val="1680"/>
-              </a:lnSpc>
-              <a:buNone/>
-            </a:pPr>
-            <a:r>
-              <a:rPr lang="en-US" sz="1200" dirty="0">
-                <a:solidFill>
-                  <a:srgbClr val="4A5468"/>
-                </a:solidFill>
-                <a:latin typeface="IBM Plex Sans" pitchFamily="34" charset="0"/>
-                <a:ea typeface="IBM Plex Sans" pitchFamily="34" charset="-122"/>
-                <a:cs typeface="IBM Plex Sans" pitchFamily="34" charset="-120"/>
-              </a:rPr>
-              <a:t>CloudLens · Capstone viva · 9</a:t>
+              <a:t>Simulated AWS accounts, made-up figures</a:t>
             </a:r>
             <a:endParaRPr lang="en-US" sz="1200" dirty="0">
               <a:latin typeface="IBM Plex Sans" charset="0"/>

</xml_diff>